<commit_message>
Quitar fotos de personas salvo en la slide de equipo
Portada, bienvenida, trabajo, resenas y 'nueva via' usan graficos de marca
(crecimiento / abstracto / cita) en vez de fotos. Aplicado en .pptx y .html.

Co-Authored-By: Claude Opus 4.8 (1M context) <noreply@anthropic.com>
</commit_message>
<xml_diff>
--- a/dist/perpetual-marketing-template.pptx
+++ b/dist/perpetual-marketing-template.pptx
@@ -3468,372 +3468,12 @@
         </p:nvSpPr>
         <p:spPr>
           <a:xfrm>
-            <a:off x="7406640" y="457200"/>
-            <a:ext cx="4297680" cy="5852160"/>
+            <a:off x="7772400" y="1234440"/>
+            <a:ext cx="3611880" cy="4160520"/>
           </a:xfrm>
           <a:prstGeom prst="roundRect">
             <a:avLst>
-              <a:gd name="adj" fmla="val 5000"/>
-            </a:avLst>
-          </a:prstGeom>
-          <a:solidFill>
-            <a:srgbClr val="DBE7FB"/>
-          </a:solidFill>
-          <a:ln>
-            <a:noFill/>
-          </a:ln>
-          <a:effectLst/>
-        </p:spPr>
-        <p:style>
-          <a:lnRef idx="1">
-            <a:schemeClr val="accent1"/>
-          </a:lnRef>
-          <a:fillRef idx="3">
-            <a:schemeClr val="accent1"/>
-          </a:fillRef>
-          <a:effectRef idx="2">
-            <a:schemeClr val="accent1"/>
-          </a:effectRef>
-          <a:fontRef idx="minor">
-            <a:schemeClr val="lt1"/>
-          </a:fontRef>
-        </p:style>
-        <p:txBody>
-          <a:bodyPr rtlCol="0" anchor="ctr"/>
-          <a:lstStyle/>
-          <a:p>
-            <a:pPr algn="ctr"/>
-          </a:p>
-        </p:txBody>
-      </p:sp>
-      <p:sp>
-        <p:nvSpPr>
-          <p:cNvPr id="7" name="Oval 6"/>
-          <p:cNvSpPr/>
-          <p:nvPr/>
-        </p:nvSpPr>
-        <p:spPr>
-          <a:xfrm>
-            <a:off x="9039758" y="2867558"/>
-            <a:ext cx="1031443" cy="1031443"/>
-          </a:xfrm>
-          <a:prstGeom prst="ellipse">
-            <a:avLst/>
-          </a:prstGeom>
-          <a:solidFill>
-            <a:srgbClr val="FFFFFF"/>
-          </a:solidFill>
-          <a:ln>
-            <a:noFill/>
-          </a:ln>
-          <a:effectLst/>
-        </p:spPr>
-        <p:style>
-          <a:lnRef idx="1">
-            <a:schemeClr val="accent1"/>
-          </a:lnRef>
-          <a:fillRef idx="3">
-            <a:schemeClr val="accent1"/>
-          </a:fillRef>
-          <a:effectRef idx="2">
-            <a:schemeClr val="accent1"/>
-          </a:effectRef>
-          <a:fontRef idx="minor">
-            <a:schemeClr val="lt1"/>
-          </a:fontRef>
-        </p:style>
-        <p:txBody>
-          <a:bodyPr rtlCol="0" anchor="ctr"/>
-          <a:lstStyle/>
-          <a:p>
-            <a:pPr algn="ctr"/>
-          </a:p>
-        </p:txBody>
-      </p:sp>
-      <p:sp>
-        <p:nvSpPr>
-          <p:cNvPr id="8" name="Oval 7"/>
-          <p:cNvSpPr/>
-          <p:nvPr/>
-        </p:nvSpPr>
-        <p:spPr>
-          <a:xfrm>
-            <a:off x="9390449" y="3218249"/>
-            <a:ext cx="330061" cy="330061"/>
-          </a:xfrm>
-          <a:prstGeom prst="ellipse">
-            <a:avLst/>
-          </a:prstGeom>
-          <a:solidFill>
-            <a:srgbClr val="1A56DB"/>
-          </a:solidFill>
-          <a:ln>
-            <a:noFill/>
-          </a:ln>
-          <a:effectLst/>
-        </p:spPr>
-        <p:style>
-          <a:lnRef idx="1">
-            <a:schemeClr val="accent1"/>
-          </a:lnRef>
-          <a:fillRef idx="3">
-            <a:schemeClr val="accent1"/>
-          </a:fillRef>
-          <a:effectRef idx="2">
-            <a:schemeClr val="accent1"/>
-          </a:effectRef>
-          <a:fontRef idx="minor">
-            <a:schemeClr val="lt1"/>
-          </a:fontRef>
-        </p:style>
-        <p:txBody>
-          <a:bodyPr rtlCol="0" anchor="ctr"/>
-          <a:lstStyle/>
-          <a:p>
-            <a:pPr algn="ctr"/>
-          </a:p>
-        </p:txBody>
-      </p:sp>
-      <p:sp>
-        <p:nvSpPr>
-          <p:cNvPr id="9" name="Oval 8"/>
-          <p:cNvSpPr/>
-          <p:nvPr/>
-        </p:nvSpPr>
-        <p:spPr>
-          <a:xfrm>
-            <a:off x="7223760" y="2743200"/>
-            <a:ext cx="822960" cy="822960"/>
-          </a:xfrm>
-          <a:prstGeom prst="ellipse">
-            <a:avLst/>
-          </a:prstGeom>
-          <a:solidFill>
-            <a:srgbClr val="FBB900"/>
-          </a:solidFill>
-          <a:ln>
-            <a:noFill/>
-          </a:ln>
-          <a:effectLst/>
-        </p:spPr>
-        <p:style>
-          <a:lnRef idx="1">
-            <a:schemeClr val="accent1"/>
-          </a:lnRef>
-          <a:fillRef idx="3">
-            <a:schemeClr val="accent1"/>
-          </a:fillRef>
-          <a:effectRef idx="2">
-            <a:schemeClr val="accent1"/>
-          </a:effectRef>
-          <a:fontRef idx="minor">
-            <a:schemeClr val="lt1"/>
-          </a:fontRef>
-        </p:style>
-        <p:txBody>
-          <a:bodyPr rtlCol="0" anchor="ctr"/>
-          <a:lstStyle/>
-          <a:p>
-            <a:pPr algn="ctr"/>
-          </a:p>
-        </p:txBody>
-      </p:sp>
-      <p:sp>
-        <p:nvSpPr>
-          <p:cNvPr id="10" name="TextBox 9"/>
-          <p:cNvSpPr txBox="1"/>
-          <p:nvPr/>
-        </p:nvSpPr>
-        <p:spPr>
-          <a:xfrm>
-            <a:off x="11247120" y="502920"/>
-            <a:ext cx="640080" cy="548640"/>
-          </a:xfrm>
-          <a:prstGeom prst="rect">
-            <a:avLst/>
-          </a:prstGeom>
-          <a:noFill/>
-        </p:spPr>
-        <p:txBody>
-          <a:bodyPr wrap="square" lIns="0" rIns="0" tIns="0" bIns="0" anchor="t">
-            <a:spAutoFit/>
-          </a:bodyPr>
-          <a:lstStyle/>
-          <a:p>
-            <a:pPr algn="l"/>
-            <a:r>
-              <a:rPr sz="3000" b="0">
-                <a:solidFill>
-                  <a:srgbClr val="1A56DB"/>
-                </a:solidFill>
-                <a:latin typeface="Armin Grotesk Black"/>
-              </a:rPr>
-              <a:t>+</a:t>
-            </a:r>
-          </a:p>
-        </p:txBody>
-      </p:sp>
-      <p:pic>
-        <p:nvPicPr>
-          <p:cNvPr id="11" name="Picture 10" descr="perpetual-color.png"/>
-          <p:cNvPicPr>
-            <a:picLocks noChangeAspect="1"/>
-          </p:cNvPicPr>
-          <p:nvPr/>
-        </p:nvPicPr>
-        <p:blipFill>
-          <a:blip r:embed="rId2"/>
-          <a:stretch>
-            <a:fillRect/>
-          </a:stretch>
-        </p:blipFill>
-        <p:spPr>
-          <a:xfrm>
-            <a:off x="640080" y="640080"/>
-            <a:ext cx="1371600" cy="164020"/>
-          </a:xfrm>
-          <a:prstGeom prst="rect">
-            <a:avLst/>
-          </a:prstGeom>
-        </p:spPr>
-      </p:pic>
-      <p:sp>
-        <p:nvSpPr>
-          <p:cNvPr id="12" name="TextBox 11"/>
-          <p:cNvSpPr txBox="1"/>
-          <p:nvPr/>
-        </p:nvSpPr>
-        <p:spPr>
-          <a:xfrm>
-            <a:off x="594360" y="1371600"/>
-            <a:ext cx="6400800" cy="1828800"/>
-          </a:xfrm>
-          <a:prstGeom prst="rect">
-            <a:avLst/>
-          </a:prstGeom>
-          <a:noFill/>
-        </p:spPr>
-        <p:txBody>
-          <a:bodyPr wrap="square" lIns="0" rIns="0" tIns="0" bIns="0" anchor="t">
-            <a:spAutoFit/>
-          </a:bodyPr>
-          <a:lstStyle/>
-          <a:p>
-            <a:pPr algn="l">
-              <a:lnSpc>
-                <a:spcPct val="98000"/>
-              </a:lnSpc>
-            </a:pPr>
-            <a:r>
-              <a:rPr sz="4600" b="0">
-                <a:solidFill>
-                  <a:srgbClr val="111827"/>
-                </a:solidFill>
-                <a:latin typeface="Armin Grotesk Black"/>
-              </a:rPr>
-              <a:t>Marketing para
-</a:t>
-            </a:r>
-            <a:r>
-              <a:rPr sz="4600" b="0">
-                <a:solidFill>
-                  <a:srgbClr val="1A56DB"/>
-                </a:solidFill>
-                <a:latin typeface="Armin Grotesk Black"/>
-              </a:rPr>
-              <a:t>tu marca.</a:t>
-            </a:r>
-          </a:p>
-        </p:txBody>
-      </p:sp>
-      <p:sp>
-        <p:nvSpPr>
-          <p:cNvPr id="13" name="TextBox 12"/>
-          <p:cNvSpPr txBox="1"/>
-          <p:nvPr/>
-        </p:nvSpPr>
-        <p:spPr>
-          <a:xfrm>
-            <a:off x="640080" y="3200400"/>
-            <a:ext cx="5669280" cy="274320"/>
-          </a:xfrm>
-          <a:prstGeom prst="rect">
-            <a:avLst/>
-          </a:prstGeom>
-          <a:noFill/>
-        </p:spPr>
-        <p:txBody>
-          <a:bodyPr wrap="square" lIns="0" rIns="0" tIns="0" bIns="0" anchor="t">
-            <a:spAutoFit/>
-          </a:bodyPr>
-          <a:lstStyle/>
-          <a:p>
-            <a:pPr algn="l"/>
-            <a:r>
-              <a:rPr sz="1300" b="0">
-                <a:solidFill>
-                  <a:srgbClr val="111827"/>
-                </a:solidFill>
-                <a:latin typeface="Armin Grotesk SemiBold"/>
-              </a:rPr>
-              <a:t>Estrategia y crecimiento</a:t>
-            </a:r>
-          </a:p>
-        </p:txBody>
-      </p:sp>
-      <p:sp>
-        <p:nvSpPr>
-          <p:cNvPr id="14" name="TextBox 13"/>
-          <p:cNvSpPr txBox="1"/>
-          <p:nvPr/>
-        </p:nvSpPr>
-        <p:spPr>
-          <a:xfrm>
-            <a:off x="640080" y="3520440"/>
-            <a:ext cx="5486400" cy="731520"/>
-          </a:xfrm>
-          <a:prstGeom prst="rect">
-            <a:avLst/>
-          </a:prstGeom>
-          <a:noFill/>
-        </p:spPr>
-        <p:txBody>
-          <a:bodyPr wrap="square" lIns="0" rIns="0" tIns="0" bIns="0" anchor="t">
-            <a:spAutoFit/>
-          </a:bodyPr>
-          <a:lstStyle/>
-          <a:p>
-            <a:pPr algn="l">
-              <a:lnSpc>
-                <a:spcPct val="130000"/>
-              </a:lnSpc>
-            </a:pPr>
-            <a:r>
-              <a:rPr sz="1250" b="0">
-                <a:solidFill>
-                  <a:srgbClr val="6B7280"/>
-                </a:solidFill>
-                <a:latin typeface="Armin Grotesk"/>
-              </a:rPr>
-              <a:t>Convertimos tu marca en resultados medibles con data y creatividad.</a:t>
-            </a:r>
-          </a:p>
-        </p:txBody>
-      </p:sp>
-      <p:sp>
-        <p:nvSpPr>
-          <p:cNvPr id="15" name="Rounded Rectangle 14"/>
-          <p:cNvSpPr/>
-          <p:nvPr/>
-        </p:nvSpPr>
-        <p:spPr>
-          <a:xfrm>
-            <a:off x="640080" y="4983480"/>
-            <a:ext cx="2743200" cy="566928"/>
-          </a:xfrm>
-          <a:prstGeom prst="roundRect">
-            <a:avLst>
-              <a:gd name="adj" fmla="val 50000"/>
+              <a:gd name="adj" fmla="val 6000"/>
             </a:avLst>
           </a:prstGeom>
           <a:solidFill>
@@ -3874,7 +3514,557 @@
       </p:sp>
       <p:sp>
         <p:nvSpPr>
+          <p:cNvPr id="7" name="Rounded Rectangle 6"/>
+          <p:cNvSpPr/>
+          <p:nvPr/>
+        </p:nvSpPr>
+        <p:spPr>
+          <a:xfrm>
+            <a:off x="8314181" y="3897172"/>
+            <a:ext cx="469544" cy="665683"/>
+          </a:xfrm>
+          <a:prstGeom prst="roundRect">
+            <a:avLst>
+              <a:gd name="adj" fmla="val 20000"/>
+            </a:avLst>
+          </a:prstGeom>
+          <a:solidFill>
+            <a:srgbClr val="1A56DB"/>
+          </a:solidFill>
+          <a:ln>
+            <a:noFill/>
+          </a:ln>
+          <a:effectLst/>
+        </p:spPr>
+        <p:style>
+          <a:lnRef idx="1">
+            <a:schemeClr val="accent1"/>
+          </a:lnRef>
+          <a:fillRef idx="3">
+            <a:schemeClr val="accent1"/>
+          </a:fillRef>
+          <a:effectRef idx="2">
+            <a:schemeClr val="accent1"/>
+          </a:effectRef>
+          <a:fontRef idx="minor">
+            <a:schemeClr val="lt1"/>
+          </a:fontRef>
+        </p:style>
+        <p:txBody>
+          <a:bodyPr rtlCol="0" anchor="ctr"/>
+          <a:lstStyle/>
+          <a:p>
+            <a:pPr algn="ctr"/>
+          </a:p>
+        </p:txBody>
+      </p:sp>
+      <p:sp>
+        <p:nvSpPr>
+          <p:cNvPr id="8" name="Rounded Rectangle 7"/>
+          <p:cNvSpPr/>
+          <p:nvPr/>
+        </p:nvSpPr>
+        <p:spPr>
+          <a:xfrm>
+            <a:off x="9000439" y="3356305"/>
+            <a:ext cx="469544" cy="1206550"/>
+          </a:xfrm>
+          <a:prstGeom prst="roundRect">
+            <a:avLst>
+              <a:gd name="adj" fmla="val 20000"/>
+            </a:avLst>
+          </a:prstGeom>
+          <a:solidFill>
+            <a:srgbClr val="F97316"/>
+          </a:solidFill>
+          <a:ln>
+            <a:noFill/>
+          </a:ln>
+          <a:effectLst/>
+        </p:spPr>
+        <p:style>
+          <a:lnRef idx="1">
+            <a:schemeClr val="accent1"/>
+          </a:lnRef>
+          <a:fillRef idx="3">
+            <a:schemeClr val="accent1"/>
+          </a:fillRef>
+          <a:effectRef idx="2">
+            <a:schemeClr val="accent1"/>
+          </a:effectRef>
+          <a:fontRef idx="minor">
+            <a:schemeClr val="lt1"/>
+          </a:fontRef>
+        </p:style>
+        <p:txBody>
+          <a:bodyPr rtlCol="0" anchor="ctr"/>
+          <a:lstStyle/>
+          <a:p>
+            <a:pPr algn="ctr"/>
+          </a:p>
+        </p:txBody>
+      </p:sp>
+      <p:sp>
+        <p:nvSpPr>
+          <p:cNvPr id="9" name="Rounded Rectangle 8"/>
+          <p:cNvSpPr/>
+          <p:nvPr/>
+        </p:nvSpPr>
+        <p:spPr>
+          <a:xfrm>
+            <a:off x="9686696" y="2815437"/>
+            <a:ext cx="469544" cy="1747418"/>
+          </a:xfrm>
+          <a:prstGeom prst="roundRect">
+            <a:avLst>
+              <a:gd name="adj" fmla="val 20000"/>
+            </a:avLst>
+          </a:prstGeom>
+          <a:solidFill>
+            <a:srgbClr val="FBB900"/>
+          </a:solidFill>
+          <a:ln>
+            <a:noFill/>
+          </a:ln>
+          <a:effectLst/>
+        </p:spPr>
+        <p:style>
+          <a:lnRef idx="1">
+            <a:schemeClr val="accent1"/>
+          </a:lnRef>
+          <a:fillRef idx="3">
+            <a:schemeClr val="accent1"/>
+          </a:fillRef>
+          <a:effectRef idx="2">
+            <a:schemeClr val="accent1"/>
+          </a:effectRef>
+          <a:fontRef idx="minor">
+            <a:schemeClr val="lt1"/>
+          </a:fontRef>
+        </p:style>
+        <p:txBody>
+          <a:bodyPr rtlCol="0" anchor="ctr"/>
+          <a:lstStyle/>
+          <a:p>
+            <a:pPr algn="ctr"/>
+          </a:p>
+        </p:txBody>
+      </p:sp>
+      <p:sp>
+        <p:nvSpPr>
+          <p:cNvPr id="10" name="Rounded Rectangle 9"/>
+          <p:cNvSpPr/>
+          <p:nvPr/>
+        </p:nvSpPr>
+        <p:spPr>
+          <a:xfrm>
+            <a:off x="10372953" y="2274570"/>
+            <a:ext cx="469544" cy="2288286"/>
+          </a:xfrm>
+          <a:prstGeom prst="roundRect">
+            <a:avLst>
+              <a:gd name="adj" fmla="val 20000"/>
+            </a:avLst>
+          </a:prstGeom>
+          <a:solidFill>
+            <a:srgbClr val="1A56DB"/>
+          </a:solidFill>
+          <a:ln>
+            <a:noFill/>
+          </a:ln>
+          <a:effectLst/>
+        </p:spPr>
+        <p:style>
+          <a:lnRef idx="1">
+            <a:schemeClr val="accent1"/>
+          </a:lnRef>
+          <a:fillRef idx="3">
+            <a:schemeClr val="accent1"/>
+          </a:fillRef>
+          <a:effectRef idx="2">
+            <a:schemeClr val="accent1"/>
+          </a:effectRef>
+          <a:fontRef idx="minor">
+            <a:schemeClr val="lt1"/>
+          </a:fontRef>
+        </p:style>
+        <p:txBody>
+          <a:bodyPr rtlCol="0" anchor="ctr"/>
+          <a:lstStyle/>
+          <a:p>
+            <a:pPr algn="ctr"/>
+          </a:p>
+        </p:txBody>
+      </p:sp>
+      <p:sp>
+        <p:nvSpPr>
+          <p:cNvPr id="11" name="Oval 10"/>
+          <p:cNvSpPr/>
+          <p:nvPr/>
+        </p:nvSpPr>
+        <p:spPr>
+          <a:xfrm>
+            <a:off x="8494776" y="1900123"/>
+            <a:ext cx="832104" cy="832104"/>
+          </a:xfrm>
+          <a:prstGeom prst="ellipse">
+            <a:avLst/>
+          </a:prstGeom>
+          <a:solidFill>
+            <a:srgbClr val="1A56DB"/>
+          </a:solidFill>
+          <a:ln>
+            <a:noFill/>
+          </a:ln>
+          <a:effectLst/>
+        </p:spPr>
+        <p:style>
+          <a:lnRef idx="1">
+            <a:schemeClr val="accent1"/>
+          </a:lnRef>
+          <a:fillRef idx="3">
+            <a:schemeClr val="accent1"/>
+          </a:fillRef>
+          <a:effectRef idx="2">
+            <a:schemeClr val="accent1"/>
+          </a:effectRef>
+          <a:fontRef idx="minor">
+            <a:schemeClr val="lt1"/>
+          </a:fontRef>
+        </p:style>
+        <p:txBody>
+          <a:bodyPr rtlCol="0" anchor="ctr"/>
+          <a:lstStyle/>
+          <a:p>
+            <a:pPr algn="ctr"/>
+          </a:p>
+        </p:txBody>
+      </p:sp>
+      <p:sp>
+        <p:nvSpPr>
+          <p:cNvPr id="12" name="Hexagon 11"/>
+          <p:cNvSpPr/>
+          <p:nvPr/>
+        </p:nvSpPr>
+        <p:spPr>
+          <a:xfrm>
+            <a:off x="10156240" y="1816912"/>
+            <a:ext cx="665683" cy="665683"/>
+          </a:xfrm>
+          <a:prstGeom prst="hexagon">
+            <a:avLst/>
+          </a:prstGeom>
+          <a:solidFill>
+            <a:srgbClr val="FBB900"/>
+          </a:solidFill>
+          <a:ln>
+            <a:noFill/>
+          </a:ln>
+          <a:effectLst/>
+        </p:spPr>
+        <p:style>
+          <a:lnRef idx="1">
+            <a:schemeClr val="accent1"/>
+          </a:lnRef>
+          <a:fillRef idx="3">
+            <a:schemeClr val="accent1"/>
+          </a:fillRef>
+          <a:effectRef idx="2">
+            <a:schemeClr val="accent1"/>
+          </a:effectRef>
+          <a:fontRef idx="minor">
+            <a:schemeClr val="lt1"/>
+          </a:fontRef>
+        </p:style>
+        <p:txBody>
+          <a:bodyPr rtlCol="0" anchor="ctr"/>
+          <a:lstStyle/>
+          <a:p>
+            <a:pPr algn="ctr"/>
+          </a:p>
+        </p:txBody>
+      </p:sp>
+      <p:sp>
+        <p:nvSpPr>
+          <p:cNvPr id="13" name="Oval 12"/>
+          <p:cNvSpPr/>
+          <p:nvPr/>
+        </p:nvSpPr>
+        <p:spPr>
+          <a:xfrm>
+            <a:off x="7223760" y="2743200"/>
+            <a:ext cx="822960" cy="822960"/>
+          </a:xfrm>
+          <a:prstGeom prst="ellipse">
+            <a:avLst/>
+          </a:prstGeom>
+          <a:solidFill>
+            <a:srgbClr val="FBB900"/>
+          </a:solidFill>
+          <a:ln>
+            <a:noFill/>
+          </a:ln>
+          <a:effectLst/>
+        </p:spPr>
+        <p:style>
+          <a:lnRef idx="1">
+            <a:schemeClr val="accent1"/>
+          </a:lnRef>
+          <a:fillRef idx="3">
+            <a:schemeClr val="accent1"/>
+          </a:fillRef>
+          <a:effectRef idx="2">
+            <a:schemeClr val="accent1"/>
+          </a:effectRef>
+          <a:fontRef idx="minor">
+            <a:schemeClr val="lt1"/>
+          </a:fontRef>
+        </p:style>
+        <p:txBody>
+          <a:bodyPr rtlCol="0" anchor="ctr"/>
+          <a:lstStyle/>
+          <a:p>
+            <a:pPr algn="ctr"/>
+          </a:p>
+        </p:txBody>
+      </p:sp>
+      <p:sp>
+        <p:nvSpPr>
+          <p:cNvPr id="14" name="TextBox 13"/>
+          <p:cNvSpPr txBox="1"/>
+          <p:nvPr/>
+        </p:nvSpPr>
+        <p:spPr>
+          <a:xfrm>
+            <a:off x="11247120" y="502920"/>
+            <a:ext cx="640080" cy="548640"/>
+          </a:xfrm>
+          <a:prstGeom prst="rect">
+            <a:avLst/>
+          </a:prstGeom>
+          <a:noFill/>
+        </p:spPr>
+        <p:txBody>
+          <a:bodyPr wrap="square" lIns="0" rIns="0" tIns="0" bIns="0" anchor="t">
+            <a:spAutoFit/>
+          </a:bodyPr>
+          <a:lstStyle/>
+          <a:p>
+            <a:pPr algn="l"/>
+            <a:r>
+              <a:rPr sz="3000" b="0">
+                <a:solidFill>
+                  <a:srgbClr val="1A56DB"/>
+                </a:solidFill>
+                <a:latin typeface="Armin Grotesk Black"/>
+              </a:rPr>
+              <a:t>+</a:t>
+            </a:r>
+          </a:p>
+        </p:txBody>
+      </p:sp>
+      <p:pic>
+        <p:nvPicPr>
+          <p:cNvPr id="15" name="Picture 14" descr="perpetual-color.png"/>
+          <p:cNvPicPr>
+            <a:picLocks noChangeAspect="1"/>
+          </p:cNvPicPr>
+          <p:nvPr/>
+        </p:nvPicPr>
+        <p:blipFill>
+          <a:blip r:embed="rId2"/>
+          <a:stretch>
+            <a:fillRect/>
+          </a:stretch>
+        </p:blipFill>
+        <p:spPr>
+          <a:xfrm>
+            <a:off x="640080" y="640080"/>
+            <a:ext cx="1371600" cy="164020"/>
+          </a:xfrm>
+          <a:prstGeom prst="rect">
+            <a:avLst/>
+          </a:prstGeom>
+        </p:spPr>
+      </p:pic>
+      <p:sp>
+        <p:nvSpPr>
           <p:cNvPr id="16" name="TextBox 15"/>
+          <p:cNvSpPr txBox="1"/>
+          <p:nvPr/>
+        </p:nvSpPr>
+        <p:spPr>
+          <a:xfrm>
+            <a:off x="594360" y="1371600"/>
+            <a:ext cx="6400800" cy="1828800"/>
+          </a:xfrm>
+          <a:prstGeom prst="rect">
+            <a:avLst/>
+          </a:prstGeom>
+          <a:noFill/>
+        </p:spPr>
+        <p:txBody>
+          <a:bodyPr wrap="square" lIns="0" rIns="0" tIns="0" bIns="0" anchor="t">
+            <a:spAutoFit/>
+          </a:bodyPr>
+          <a:lstStyle/>
+          <a:p>
+            <a:pPr algn="l">
+              <a:lnSpc>
+                <a:spcPct val="98000"/>
+              </a:lnSpc>
+            </a:pPr>
+            <a:r>
+              <a:rPr sz="4600" b="0">
+                <a:solidFill>
+                  <a:srgbClr val="111827"/>
+                </a:solidFill>
+                <a:latin typeface="Armin Grotesk Black"/>
+              </a:rPr>
+              <a:t>Marketing para
+</a:t>
+            </a:r>
+            <a:r>
+              <a:rPr sz="4600" b="0">
+                <a:solidFill>
+                  <a:srgbClr val="1A56DB"/>
+                </a:solidFill>
+                <a:latin typeface="Armin Grotesk Black"/>
+              </a:rPr>
+              <a:t>tu marca.</a:t>
+            </a:r>
+          </a:p>
+        </p:txBody>
+      </p:sp>
+      <p:sp>
+        <p:nvSpPr>
+          <p:cNvPr id="17" name="TextBox 16"/>
+          <p:cNvSpPr txBox="1"/>
+          <p:nvPr/>
+        </p:nvSpPr>
+        <p:spPr>
+          <a:xfrm>
+            <a:off x="640080" y="3200400"/>
+            <a:ext cx="5669280" cy="274320"/>
+          </a:xfrm>
+          <a:prstGeom prst="rect">
+            <a:avLst/>
+          </a:prstGeom>
+          <a:noFill/>
+        </p:spPr>
+        <p:txBody>
+          <a:bodyPr wrap="square" lIns="0" rIns="0" tIns="0" bIns="0" anchor="t">
+            <a:spAutoFit/>
+          </a:bodyPr>
+          <a:lstStyle/>
+          <a:p>
+            <a:pPr algn="l"/>
+            <a:r>
+              <a:rPr sz="1300" b="0">
+                <a:solidFill>
+                  <a:srgbClr val="111827"/>
+                </a:solidFill>
+                <a:latin typeface="Armin Grotesk SemiBold"/>
+              </a:rPr>
+              <a:t>Estrategia y crecimiento</a:t>
+            </a:r>
+          </a:p>
+        </p:txBody>
+      </p:sp>
+      <p:sp>
+        <p:nvSpPr>
+          <p:cNvPr id="18" name="TextBox 17"/>
+          <p:cNvSpPr txBox="1"/>
+          <p:nvPr/>
+        </p:nvSpPr>
+        <p:spPr>
+          <a:xfrm>
+            <a:off x="640080" y="3520440"/>
+            <a:ext cx="5486400" cy="731520"/>
+          </a:xfrm>
+          <a:prstGeom prst="rect">
+            <a:avLst/>
+          </a:prstGeom>
+          <a:noFill/>
+        </p:spPr>
+        <p:txBody>
+          <a:bodyPr wrap="square" lIns="0" rIns="0" tIns="0" bIns="0" anchor="t">
+            <a:spAutoFit/>
+          </a:bodyPr>
+          <a:lstStyle/>
+          <a:p>
+            <a:pPr algn="l">
+              <a:lnSpc>
+                <a:spcPct val="130000"/>
+              </a:lnSpc>
+            </a:pPr>
+            <a:r>
+              <a:rPr sz="1250" b="0">
+                <a:solidFill>
+                  <a:srgbClr val="6B7280"/>
+                </a:solidFill>
+                <a:latin typeface="Armin Grotesk"/>
+              </a:rPr>
+              <a:t>Convertimos tu marca en resultados medibles con data y creatividad.</a:t>
+            </a:r>
+          </a:p>
+        </p:txBody>
+      </p:sp>
+      <p:sp>
+        <p:nvSpPr>
+          <p:cNvPr id="19" name="Rounded Rectangle 18"/>
+          <p:cNvSpPr/>
+          <p:nvPr/>
+        </p:nvSpPr>
+        <p:spPr>
+          <a:xfrm>
+            <a:off x="640080" y="4983480"/>
+            <a:ext cx="2743200" cy="566928"/>
+          </a:xfrm>
+          <a:prstGeom prst="roundRect">
+            <a:avLst>
+              <a:gd name="adj" fmla="val 50000"/>
+            </a:avLst>
+          </a:prstGeom>
+          <a:solidFill>
+            <a:srgbClr val="FFFFFF"/>
+          </a:solidFill>
+          <a:ln>
+            <a:noFill/>
+          </a:ln>
+          <a:effectLst>
+            <a:outerShdw blurRad="152400" dist="38100" dir="5400000" rotWithShape="0">
+              <a:srgbClr val="1A2B5C">
+                <a:alpha val="12000"/>
+              </a:srgbClr>
+            </a:outerShdw>
+          </a:effectLst>
+        </p:spPr>
+        <p:style>
+          <a:lnRef idx="1">
+            <a:schemeClr val="accent1"/>
+          </a:lnRef>
+          <a:fillRef idx="3">
+            <a:schemeClr val="accent1"/>
+          </a:fillRef>
+          <a:effectRef idx="2">
+            <a:schemeClr val="accent1"/>
+          </a:effectRef>
+          <a:fontRef idx="minor">
+            <a:schemeClr val="lt1"/>
+          </a:fontRef>
+        </p:style>
+        <p:txBody>
+          <a:bodyPr rtlCol="0" anchor="ctr"/>
+          <a:lstStyle/>
+          <a:p>
+            <a:pPr algn="ctr"/>
+          </a:p>
+        </p:txBody>
+      </p:sp>
+      <p:sp>
+        <p:nvSpPr>
+          <p:cNvPr id="20" name="TextBox 19"/>
           <p:cNvSpPr txBox="1"/>
           <p:nvPr/>
         </p:nvSpPr>
@@ -3909,7 +4099,7 @@
       </p:sp>
       <p:sp>
         <p:nvSpPr>
-          <p:cNvPr id="17" name="Oval 16"/>
+          <p:cNvPr id="21" name="Oval 20"/>
           <p:cNvSpPr/>
           <p:nvPr/>
         </p:nvSpPr>
@@ -3953,7 +4143,7 @@
       </p:sp>
       <p:sp>
         <p:nvSpPr>
-          <p:cNvPr id="18" name="TextBox 17"/>
+          <p:cNvPr id="22" name="TextBox 21"/>
           <p:cNvSpPr txBox="1"/>
           <p:nvPr/>
         </p:nvSpPr>
@@ -4138,10 +4328,142 @@
         </p:nvSpPr>
         <p:spPr>
           <a:xfrm>
-            <a:off x="1751990" y="3763670"/>
-            <a:ext cx="702259" cy="702259"/>
+            <a:off x="1283817" y="3588105"/>
+            <a:ext cx="1119225" cy="1119225"/>
           </a:xfrm>
           <a:prstGeom prst="ellipse">
+            <a:avLst/>
+          </a:prstGeom>
+          <a:solidFill>
+            <a:srgbClr val="1A56DB"/>
+          </a:solidFill>
+          <a:ln>
+            <a:noFill/>
+          </a:ln>
+          <a:effectLst/>
+        </p:spPr>
+        <p:style>
+          <a:lnRef idx="1">
+            <a:schemeClr val="accent1"/>
+          </a:lnRef>
+          <a:fillRef idx="3">
+            <a:schemeClr val="accent1"/>
+          </a:fillRef>
+          <a:effectRef idx="2">
+            <a:schemeClr val="accent1"/>
+          </a:effectRef>
+          <a:fontRef idx="minor">
+            <a:schemeClr val="lt1"/>
+          </a:fontRef>
+        </p:style>
+        <p:txBody>
+          <a:bodyPr rtlCol="0" anchor="ctr"/>
+          <a:lstStyle/>
+          <a:p>
+            <a:pPr algn="ctr"/>
+          </a:p>
+        </p:txBody>
+      </p:sp>
+      <p:sp>
+        <p:nvSpPr>
+          <p:cNvPr id="6" name="Oval 5"/>
+          <p:cNvSpPr/>
+          <p:nvPr/>
+        </p:nvSpPr>
+        <p:spPr>
+          <a:xfrm>
+            <a:off x="2190902" y="4048963"/>
+            <a:ext cx="724204" cy="724204"/>
+          </a:xfrm>
+          <a:prstGeom prst="ellipse">
+            <a:avLst/>
+          </a:prstGeom>
+          <a:solidFill>
+            <a:srgbClr val="F97316"/>
+          </a:solidFill>
+          <a:ln>
+            <a:noFill/>
+          </a:ln>
+          <a:effectLst/>
+        </p:spPr>
+        <p:style>
+          <a:lnRef idx="1">
+            <a:schemeClr val="accent1"/>
+          </a:lnRef>
+          <a:fillRef idx="3">
+            <a:schemeClr val="accent1"/>
+          </a:fillRef>
+          <a:effectRef idx="2">
+            <a:schemeClr val="accent1"/>
+          </a:effectRef>
+          <a:fontRef idx="minor">
+            <a:schemeClr val="lt1"/>
+          </a:fontRef>
+        </p:style>
+        <p:txBody>
+          <a:bodyPr rtlCol="0" anchor="ctr"/>
+          <a:lstStyle/>
+          <a:p>
+            <a:pPr algn="ctr"/>
+          </a:p>
+        </p:txBody>
+      </p:sp>
+      <p:sp>
+        <p:nvSpPr>
+          <p:cNvPr id="7" name="Oval 6"/>
+          <p:cNvSpPr/>
+          <p:nvPr/>
+        </p:nvSpPr>
+        <p:spPr>
+          <a:xfrm>
+            <a:off x="2044598" y="4641494"/>
+            <a:ext cx="427939" cy="427939"/>
+          </a:xfrm>
+          <a:prstGeom prst="ellipse">
+            <a:avLst/>
+          </a:prstGeom>
+          <a:solidFill>
+            <a:srgbClr val="FBB900"/>
+          </a:solidFill>
+          <a:ln>
+            <a:noFill/>
+          </a:ln>
+          <a:effectLst/>
+        </p:spPr>
+        <p:style>
+          <a:lnRef idx="1">
+            <a:schemeClr val="accent1"/>
+          </a:lnRef>
+          <a:fillRef idx="3">
+            <a:schemeClr val="accent1"/>
+          </a:fillRef>
+          <a:effectRef idx="2">
+            <a:schemeClr val="accent1"/>
+          </a:effectRef>
+          <a:fontRef idx="minor">
+            <a:schemeClr val="lt1"/>
+          </a:fontRef>
+        </p:style>
+        <p:txBody>
+          <a:bodyPr rtlCol="0" anchor="ctr"/>
+          <a:lstStyle/>
+          <a:p>
+            <a:pPr algn="ctr"/>
+          </a:p>
+        </p:txBody>
+      </p:sp>
+      <p:sp>
+        <p:nvSpPr>
+          <p:cNvPr id="8" name="Hexagon 7"/>
+          <p:cNvSpPr/>
+          <p:nvPr/>
+        </p:nvSpPr>
+        <p:spPr>
+          <a:xfrm>
+            <a:off x="2454249" y="3258921"/>
+            <a:ext cx="559612" cy="559612"/>
+          </a:xfrm>
+          <a:prstGeom prst="hexagon">
             <a:avLst/>
           </a:prstGeom>
           <a:solidFill>
@@ -4176,14 +4498,14 @@
       </p:sp>
       <p:sp>
         <p:nvSpPr>
-          <p:cNvPr id="6" name="Oval 5"/>
+          <p:cNvPr id="9" name="Oval 8"/>
           <p:cNvSpPr/>
           <p:nvPr/>
         </p:nvSpPr>
         <p:spPr>
           <a:xfrm>
-            <a:off x="1990758" y="4002438"/>
-            <a:ext cx="224722" cy="224722"/>
+            <a:off x="4023360" y="2377440"/>
+            <a:ext cx="777240" cy="777240"/>
           </a:xfrm>
           <a:prstGeom prst="ellipse">
             <a:avLst/>
@@ -4220,51 +4542,7 @@
       </p:sp>
       <p:sp>
         <p:nvSpPr>
-          <p:cNvPr id="7" name="Oval 6"/>
-          <p:cNvSpPr/>
-          <p:nvPr/>
-        </p:nvSpPr>
-        <p:spPr>
-          <a:xfrm>
-            <a:off x="4023360" y="2377440"/>
-            <a:ext cx="777240" cy="777240"/>
-          </a:xfrm>
-          <a:prstGeom prst="ellipse">
-            <a:avLst/>
-          </a:prstGeom>
-          <a:solidFill>
-            <a:srgbClr val="1A56DB"/>
-          </a:solidFill>
-          <a:ln>
-            <a:noFill/>
-          </a:ln>
-          <a:effectLst/>
-        </p:spPr>
-        <p:style>
-          <a:lnRef idx="1">
-            <a:schemeClr val="accent1"/>
-          </a:lnRef>
-          <a:fillRef idx="3">
-            <a:schemeClr val="accent1"/>
-          </a:fillRef>
-          <a:effectRef idx="2">
-            <a:schemeClr val="accent1"/>
-          </a:effectRef>
-          <a:fontRef idx="minor">
-            <a:schemeClr val="lt1"/>
-          </a:fontRef>
-        </p:style>
-        <p:txBody>
-          <a:bodyPr rtlCol="0" anchor="ctr"/>
-          <a:lstStyle/>
-          <a:p>
-            <a:pPr algn="ctr"/>
-          </a:p>
-        </p:txBody>
-      </p:sp>
-      <p:sp>
-        <p:nvSpPr>
-          <p:cNvPr id="8" name="Hexagon 7"/>
+          <p:cNvPr id="10" name="Hexagon 9"/>
           <p:cNvSpPr/>
           <p:nvPr/>
         </p:nvSpPr>
@@ -4308,7 +4586,7 @@
       </p:sp>
       <p:sp>
         <p:nvSpPr>
-          <p:cNvPr id="9" name="TextBox 8"/>
+          <p:cNvPr id="11" name="TextBox 10"/>
           <p:cNvSpPr txBox="1"/>
           <p:nvPr/>
         </p:nvSpPr>
@@ -4343,7 +4621,7 @@
       </p:sp>
       <p:sp>
         <p:nvSpPr>
-          <p:cNvPr id="10" name="TextBox 9"/>
+          <p:cNvPr id="12" name="TextBox 11"/>
           <p:cNvSpPr txBox="1"/>
           <p:nvPr/>
         </p:nvSpPr>
@@ -4378,7 +4656,7 @@
       </p:sp>
       <p:sp>
         <p:nvSpPr>
-          <p:cNvPr id="11" name="TextBox 10"/>
+          <p:cNvPr id="13" name="TextBox 12"/>
           <p:cNvSpPr txBox="1"/>
           <p:nvPr/>
         </p:nvSpPr>
@@ -4413,7 +4691,7 @@
       </p:sp>
       <p:sp>
         <p:nvSpPr>
-          <p:cNvPr id="12" name="Oval 11"/>
+          <p:cNvPr id="14" name="Oval 13"/>
           <p:cNvSpPr/>
           <p:nvPr/>
         </p:nvSpPr>
@@ -4457,7 +4735,7 @@
       </p:sp>
       <p:sp>
         <p:nvSpPr>
-          <p:cNvPr id="13" name="Hexagon 12"/>
+          <p:cNvPr id="15" name="Hexagon 14"/>
           <p:cNvSpPr/>
           <p:nvPr/>
         </p:nvSpPr>
@@ -4501,7 +4779,7 @@
       </p:sp>
       <p:sp>
         <p:nvSpPr>
-          <p:cNvPr id="14" name="TextBox 13"/>
+          <p:cNvPr id="16" name="TextBox 15"/>
           <p:cNvSpPr txBox="1"/>
           <p:nvPr/>
         </p:nvSpPr>
@@ -4536,7 +4814,7 @@
       </p:sp>
       <p:sp>
         <p:nvSpPr>
-          <p:cNvPr id="15" name="TextBox 14"/>
+          <p:cNvPr id="17" name="TextBox 16"/>
           <p:cNvSpPr txBox="1"/>
           <p:nvPr/>
         </p:nvSpPr>
@@ -4571,7 +4849,7 @@
       </p:sp>
       <p:sp>
         <p:nvSpPr>
-          <p:cNvPr id="16" name="TextBox 15"/>
+          <p:cNvPr id="18" name="TextBox 17"/>
           <p:cNvSpPr txBox="1"/>
           <p:nvPr/>
         </p:nvSpPr>
@@ -4606,7 +4884,7 @@
       </p:sp>
       <p:sp>
         <p:nvSpPr>
-          <p:cNvPr id="17" name="Oval 16"/>
+          <p:cNvPr id="19" name="Oval 18"/>
           <p:cNvSpPr/>
           <p:nvPr/>
         </p:nvSpPr>
@@ -4650,7 +4928,7 @@
       </p:sp>
       <p:sp>
         <p:nvSpPr>
-          <p:cNvPr id="18" name="Hexagon 17"/>
+          <p:cNvPr id="20" name="Hexagon 19"/>
           <p:cNvSpPr/>
           <p:nvPr/>
         </p:nvSpPr>
@@ -4694,7 +4972,7 @@
       </p:sp>
       <p:sp>
         <p:nvSpPr>
-          <p:cNvPr id="19" name="TextBox 18"/>
+          <p:cNvPr id="21" name="TextBox 20"/>
           <p:cNvSpPr txBox="1"/>
           <p:nvPr/>
         </p:nvSpPr>
@@ -4729,7 +5007,7 @@
       </p:sp>
       <p:sp>
         <p:nvSpPr>
-          <p:cNvPr id="20" name="TextBox 19"/>
+          <p:cNvPr id="22" name="TextBox 21"/>
           <p:cNvSpPr txBox="1"/>
           <p:nvPr/>
         </p:nvSpPr>
@@ -4764,7 +5042,7 @@
       </p:sp>
       <p:sp>
         <p:nvSpPr>
-          <p:cNvPr id="21" name="TextBox 20"/>
+          <p:cNvPr id="23" name="TextBox 22"/>
           <p:cNvSpPr txBox="1"/>
           <p:nvPr/>
         </p:nvSpPr>
@@ -4799,7 +5077,7 @@
       </p:sp>
       <p:sp>
         <p:nvSpPr>
-          <p:cNvPr id="22" name="Oval 21"/>
+          <p:cNvPr id="24" name="Oval 23"/>
           <p:cNvSpPr/>
           <p:nvPr/>
         </p:nvSpPr>
@@ -4843,7 +5121,7 @@
       </p:sp>
       <p:sp>
         <p:nvSpPr>
-          <p:cNvPr id="23" name="Hexagon 22"/>
+          <p:cNvPr id="25" name="Hexagon 24"/>
           <p:cNvSpPr/>
           <p:nvPr/>
         </p:nvSpPr>
@@ -4887,7 +5165,7 @@
       </p:sp>
       <p:sp>
         <p:nvSpPr>
-          <p:cNvPr id="24" name="TextBox 23"/>
+          <p:cNvPr id="26" name="TextBox 25"/>
           <p:cNvSpPr txBox="1"/>
           <p:nvPr/>
         </p:nvSpPr>
@@ -4922,7 +5200,7 @@
       </p:sp>
       <p:sp>
         <p:nvSpPr>
-          <p:cNvPr id="25" name="TextBox 24"/>
+          <p:cNvPr id="27" name="TextBox 26"/>
           <p:cNvSpPr txBox="1"/>
           <p:nvPr/>
         </p:nvSpPr>
@@ -4957,7 +5235,7 @@
       </p:sp>
       <p:sp>
         <p:nvSpPr>
-          <p:cNvPr id="26" name="TextBox 25"/>
+          <p:cNvPr id="28" name="TextBox 27"/>
           <p:cNvSpPr txBox="1"/>
           <p:nvPr/>
         </p:nvSpPr>
@@ -4992,7 +5270,7 @@
       </p:sp>
       <p:pic>
         <p:nvPicPr>
-          <p:cNvPr id="27" name="Picture 26" descr="perpetual-color.png"/>
+          <p:cNvPr id="29" name="Picture 28" descr="perpetual-color.png"/>
           <p:cNvPicPr>
             <a:picLocks noChangeAspect="1"/>
           </p:cNvPicPr>
@@ -5016,7 +5294,7 @@
       </p:pic>
       <p:sp>
         <p:nvSpPr>
-          <p:cNvPr id="28" name="TextBox 27"/>
+          <p:cNvPr id="30" name="TextBox 29"/>
           <p:cNvSpPr txBox="1"/>
           <p:nvPr/>
         </p:nvSpPr>
@@ -5051,7 +5329,7 @@
       </p:sp>
       <p:sp>
         <p:nvSpPr>
-          <p:cNvPr id="29" name="TextBox 28"/>
+          <p:cNvPr id="31" name="TextBox 30"/>
           <p:cNvSpPr txBox="1"/>
           <p:nvPr/>
         </p:nvSpPr>
@@ -7263,10 +7541,142 @@
         </p:nvSpPr>
         <p:spPr>
           <a:xfrm>
-            <a:off x="5934455" y="2779776"/>
-            <a:ext cx="658368" cy="658368"/>
+            <a:off x="5162702" y="2670048"/>
+            <a:ext cx="932688" cy="932688"/>
           </a:xfrm>
           <a:prstGeom prst="ellipse">
+            <a:avLst/>
+          </a:prstGeom>
+          <a:solidFill>
+            <a:srgbClr val="1A56DB"/>
+          </a:solidFill>
+          <a:ln>
+            <a:noFill/>
+          </a:ln>
+          <a:effectLst/>
+        </p:spPr>
+        <p:style>
+          <a:lnRef idx="1">
+            <a:schemeClr val="accent1"/>
+          </a:lnRef>
+          <a:fillRef idx="3">
+            <a:schemeClr val="accent1"/>
+          </a:fillRef>
+          <a:effectRef idx="2">
+            <a:schemeClr val="accent1"/>
+          </a:effectRef>
+          <a:fontRef idx="minor">
+            <a:schemeClr val="lt1"/>
+          </a:fontRef>
+        </p:style>
+        <p:txBody>
+          <a:bodyPr rtlCol="0" anchor="ctr"/>
+          <a:lstStyle/>
+          <a:p>
+            <a:pPr algn="ctr"/>
+          </a:p>
+        </p:txBody>
+      </p:sp>
+      <p:sp>
+        <p:nvSpPr>
+          <p:cNvPr id="7" name="Oval 6"/>
+          <p:cNvSpPr/>
+          <p:nvPr/>
+        </p:nvSpPr>
+        <p:spPr>
+          <a:xfrm>
+            <a:off x="6381597" y="3054096"/>
+            <a:ext cx="603504" cy="603504"/>
+          </a:xfrm>
+          <a:prstGeom prst="ellipse">
+            <a:avLst/>
+          </a:prstGeom>
+          <a:solidFill>
+            <a:srgbClr val="F97316"/>
+          </a:solidFill>
+          <a:ln>
+            <a:noFill/>
+          </a:ln>
+          <a:effectLst/>
+        </p:spPr>
+        <p:style>
+          <a:lnRef idx="1">
+            <a:schemeClr val="accent1"/>
+          </a:lnRef>
+          <a:fillRef idx="3">
+            <a:schemeClr val="accent1"/>
+          </a:fillRef>
+          <a:effectRef idx="2">
+            <a:schemeClr val="accent1"/>
+          </a:effectRef>
+          <a:fontRef idx="minor">
+            <a:schemeClr val="lt1"/>
+          </a:fontRef>
+        </p:style>
+        <p:txBody>
+          <a:bodyPr rtlCol="0" anchor="ctr"/>
+          <a:lstStyle/>
+          <a:p>
+            <a:pPr algn="ctr"/>
+          </a:p>
+        </p:txBody>
+      </p:sp>
+      <p:sp>
+        <p:nvSpPr>
+          <p:cNvPr id="8" name="Oval 7"/>
+          <p:cNvSpPr/>
+          <p:nvPr/>
+        </p:nvSpPr>
+        <p:spPr>
+          <a:xfrm>
+            <a:off x="6185001" y="3547872"/>
+            <a:ext cx="356616" cy="356616"/>
+          </a:xfrm>
+          <a:prstGeom prst="ellipse">
+            <a:avLst/>
+          </a:prstGeom>
+          <a:solidFill>
+            <a:srgbClr val="FBB900"/>
+          </a:solidFill>
+          <a:ln>
+            <a:noFill/>
+          </a:ln>
+          <a:effectLst/>
+        </p:spPr>
+        <p:style>
+          <a:lnRef idx="1">
+            <a:schemeClr val="accent1"/>
+          </a:lnRef>
+          <a:fillRef idx="3">
+            <a:schemeClr val="accent1"/>
+          </a:fillRef>
+          <a:effectRef idx="2">
+            <a:schemeClr val="accent1"/>
+          </a:effectRef>
+          <a:fontRef idx="minor">
+            <a:schemeClr val="lt1"/>
+          </a:fontRef>
+        </p:style>
+        <p:txBody>
+          <a:bodyPr rtlCol="0" anchor="ctr"/>
+          <a:lstStyle/>
+          <a:p>
+            <a:pPr algn="ctr"/>
+          </a:p>
+        </p:txBody>
+      </p:sp>
+      <p:sp>
+        <p:nvSpPr>
+          <p:cNvPr id="9" name="Hexagon 8"/>
+          <p:cNvSpPr/>
+          <p:nvPr/>
+        </p:nvSpPr>
+        <p:spPr>
+          <a:xfrm>
+            <a:off x="6735470" y="2395728"/>
+            <a:ext cx="466344" cy="466344"/>
+          </a:xfrm>
+          <a:prstGeom prst="hexagon">
             <a:avLst/>
           </a:prstGeom>
           <a:solidFill>
@@ -7301,17 +7711,255 @@
       </p:sp>
       <p:sp>
         <p:nvSpPr>
-          <p:cNvPr id="7" name="Oval 6"/>
+          <p:cNvPr id="10" name="Rounded Rectangle 9"/>
           <p:cNvSpPr/>
           <p:nvPr/>
         </p:nvSpPr>
         <p:spPr>
           <a:xfrm>
-            <a:off x="6158301" y="3003621"/>
-            <a:ext cx="210677" cy="210677"/>
-          </a:xfrm>
-          <a:prstGeom prst="ellipse">
-            <a:avLst/>
+            <a:off x="4572000" y="4160520"/>
+            <a:ext cx="2468880" cy="310896"/>
+          </a:xfrm>
+          <a:prstGeom prst="roundRect">
+            <a:avLst>
+              <a:gd name="adj" fmla="val 50000"/>
+            </a:avLst>
+          </a:prstGeom>
+          <a:solidFill>
+            <a:srgbClr val="F97316"/>
+          </a:solidFill>
+          <a:ln>
+            <a:noFill/>
+          </a:ln>
+          <a:effectLst/>
+        </p:spPr>
+        <p:style>
+          <a:lnRef idx="1">
+            <a:schemeClr val="accent1"/>
+          </a:lnRef>
+          <a:fillRef idx="3">
+            <a:schemeClr val="accent1"/>
+          </a:fillRef>
+          <a:effectRef idx="2">
+            <a:schemeClr val="accent1"/>
+          </a:effectRef>
+          <a:fontRef idx="minor">
+            <a:schemeClr val="lt1"/>
+          </a:fontRef>
+        </p:style>
+        <p:txBody>
+          <a:bodyPr rtlCol="0" anchor="ctr"/>
+          <a:lstStyle/>
+          <a:p>
+            <a:pPr algn="ctr"/>
+          </a:p>
+        </p:txBody>
+      </p:sp>
+      <p:sp>
+        <p:nvSpPr>
+          <p:cNvPr id="11" name="TextBox 10"/>
+          <p:cNvSpPr txBox="1"/>
+          <p:nvPr/>
+        </p:nvSpPr>
+        <p:spPr>
+          <a:xfrm>
+            <a:off x="4572000" y="4160520"/>
+            <a:ext cx="2468880" cy="310896"/>
+          </a:xfrm>
+          <a:prstGeom prst="rect">
+            <a:avLst/>
+          </a:prstGeom>
+          <a:noFill/>
+        </p:spPr>
+        <p:txBody>
+          <a:bodyPr wrap="square" lIns="0" rIns="0" tIns="0" bIns="0" anchor="ctr">
+            <a:spAutoFit/>
+          </a:bodyPr>
+          <a:lstStyle/>
+          <a:p>
+            <a:pPr algn="ctr"/>
+            <a:r>
+              <a:rPr sz="1050" b="0" spc="120">
+                <a:solidFill>
+                  <a:srgbClr val="FFFFFF"/>
+                </a:solidFill>
+                <a:latin typeface="Armin Grotesk SemiBold"/>
+              </a:rPr>
+              <a:t>SOPORTE DE MARKETING</a:t>
+            </a:r>
+          </a:p>
+        </p:txBody>
+      </p:sp>
+      <p:sp>
+        <p:nvSpPr>
+          <p:cNvPr id="12" name="TextBox 11"/>
+          <p:cNvSpPr txBox="1"/>
+          <p:nvPr/>
+        </p:nvSpPr>
+        <p:spPr>
+          <a:xfrm>
+            <a:off x="640080" y="2377440"/>
+            <a:ext cx="3200400" cy="548640"/>
+          </a:xfrm>
+          <a:prstGeom prst="rect">
+            <a:avLst/>
+          </a:prstGeom>
+          <a:noFill/>
+        </p:spPr>
+        <p:txBody>
+          <a:bodyPr wrap="square" lIns="0" rIns="0" tIns="0" bIns="0" anchor="t">
+            <a:spAutoFit/>
+          </a:bodyPr>
+          <a:lstStyle/>
+          <a:p>
+            <a:pPr algn="l"/>
+            <a:r>
+              <a:rPr sz="4000" b="0">
+                <a:solidFill>
+                  <a:srgbClr val="1A56DB"/>
+                </a:solidFill>
+                <a:latin typeface="Armin Grotesk Black"/>
+              </a:rPr>
+              <a:t>2.9M</a:t>
+            </a:r>
+          </a:p>
+        </p:txBody>
+      </p:sp>
+      <p:sp>
+        <p:nvSpPr>
+          <p:cNvPr id="13" name="TextBox 12"/>
+          <p:cNvSpPr txBox="1"/>
+          <p:nvPr/>
+        </p:nvSpPr>
+        <p:spPr>
+          <a:xfrm>
+            <a:off x="640080" y="3008060"/>
+            <a:ext cx="3200400" cy="320040"/>
+          </a:xfrm>
+          <a:prstGeom prst="rect">
+            <a:avLst/>
+          </a:prstGeom>
+          <a:noFill/>
+        </p:spPr>
+        <p:txBody>
+          <a:bodyPr wrap="square" lIns="0" rIns="0" tIns="0" bIns="0" anchor="t">
+            <a:spAutoFit/>
+          </a:bodyPr>
+          <a:lstStyle/>
+          <a:p>
+            <a:pPr algn="l"/>
+            <a:r>
+              <a:rPr sz="1100" b="0" spc="60">
+                <a:solidFill>
+                  <a:srgbClr val="6B7280"/>
+                </a:solidFill>
+                <a:latin typeface="Armin Grotesk SemiBold"/>
+              </a:rPr>
+              <a:t>IMPRESIONES GESTIONADAS</a:t>
+            </a:r>
+          </a:p>
+        </p:txBody>
+      </p:sp>
+      <p:sp>
+        <p:nvSpPr>
+          <p:cNvPr id="14" name="TextBox 13"/>
+          <p:cNvSpPr txBox="1"/>
+          <p:nvPr/>
+        </p:nvSpPr>
+        <p:spPr>
+          <a:xfrm>
+            <a:off x="640080" y="3566160"/>
+            <a:ext cx="3291840" cy="2286000"/>
+          </a:xfrm>
+          <a:prstGeom prst="rect">
+            <a:avLst/>
+          </a:prstGeom>
+          <a:noFill/>
+        </p:spPr>
+        <p:txBody>
+          <a:bodyPr wrap="square" lIns="0" rIns="0" tIns="0" bIns="0" anchor="t">
+            <a:spAutoFit/>
+          </a:bodyPr>
+          <a:lstStyle/>
+          <a:p>
+            <a:pPr algn="l">
+              <a:lnSpc>
+                <a:spcPct val="135000"/>
+              </a:lnSpc>
+            </a:pPr>
+            <a:r>
+              <a:rPr sz="1250" b="0">
+                <a:solidFill>
+                  <a:srgbClr val="6B7280"/>
+                </a:solidFill>
+                <a:latin typeface="Armin Grotesk"/>
+              </a:rPr>
+              <a:t>Acompanamos a tu equipo de principio a fin: estrategia, ejecucion y medicion en un solo lugar.</a:t>
+            </a:r>
+          </a:p>
+        </p:txBody>
+      </p:sp>
+      <p:sp>
+        <p:nvSpPr>
+          <p:cNvPr id="15" name="Rounded Rectangle 14"/>
+          <p:cNvSpPr/>
+          <p:nvPr/>
+        </p:nvSpPr>
+        <p:spPr>
+          <a:xfrm>
+            <a:off x="8595360" y="2103120"/>
+            <a:ext cx="3017520" cy="3291840"/>
+          </a:xfrm>
+          <a:prstGeom prst="roundRect">
+            <a:avLst>
+              <a:gd name="adj" fmla="val 6000"/>
+            </a:avLst>
+          </a:prstGeom>
+          <a:solidFill>
+            <a:srgbClr val="FDE9D6"/>
+          </a:solidFill>
+          <a:ln>
+            <a:noFill/>
+          </a:ln>
+          <a:effectLst/>
+        </p:spPr>
+        <p:style>
+          <a:lnRef idx="1">
+            <a:schemeClr val="accent1"/>
+          </a:lnRef>
+          <a:fillRef idx="3">
+            <a:schemeClr val="accent1"/>
+          </a:fillRef>
+          <a:effectRef idx="2">
+            <a:schemeClr val="accent1"/>
+          </a:effectRef>
+          <a:fontRef idx="minor">
+            <a:schemeClr val="lt1"/>
+          </a:fontRef>
+        </p:style>
+        <p:txBody>
+          <a:bodyPr rtlCol="0" anchor="ctr"/>
+          <a:lstStyle/>
+          <a:p>
+            <a:pPr algn="ctr"/>
+          </a:p>
+        </p:txBody>
+      </p:sp>
+      <p:sp>
+        <p:nvSpPr>
+          <p:cNvPr id="16" name="Rounded Rectangle 15"/>
+          <p:cNvSpPr/>
+          <p:nvPr/>
+        </p:nvSpPr>
+        <p:spPr>
+          <a:xfrm>
+            <a:off x="9047988" y="4209897"/>
+            <a:ext cx="392277" cy="526694"/>
+          </a:xfrm>
+          <a:prstGeom prst="roundRect">
+            <a:avLst>
+              <a:gd name="adj" fmla="val 20000"/>
+            </a:avLst>
           </a:prstGeom>
           <a:solidFill>
             <a:srgbClr val="1A56DB"/>
@@ -7345,18 +7993,18 @@
       </p:sp>
       <p:sp>
         <p:nvSpPr>
-          <p:cNvPr id="8" name="Rounded Rectangle 7"/>
+          <p:cNvPr id="17" name="Rounded Rectangle 16"/>
           <p:cNvSpPr/>
           <p:nvPr/>
         </p:nvSpPr>
         <p:spPr>
           <a:xfrm>
-            <a:off x="4572000" y="4160520"/>
-            <a:ext cx="2468880" cy="310896"/>
+            <a:off x="9621316" y="3781958"/>
+            <a:ext cx="392277" cy="954633"/>
           </a:xfrm>
           <a:prstGeom prst="roundRect">
             <a:avLst>
-              <a:gd name="adj" fmla="val 50000"/>
+              <a:gd name="adj" fmla="val 20000"/>
             </a:avLst>
           </a:prstGeom>
           <a:solidFill>
@@ -7391,166 +8039,22 @@
       </p:sp>
       <p:sp>
         <p:nvSpPr>
-          <p:cNvPr id="9" name="TextBox 8"/>
-          <p:cNvSpPr txBox="1"/>
-          <p:nvPr/>
-        </p:nvSpPr>
-        <p:spPr>
-          <a:xfrm>
-            <a:off x="4572000" y="4160520"/>
-            <a:ext cx="2468880" cy="310896"/>
-          </a:xfrm>
-          <a:prstGeom prst="rect">
-            <a:avLst/>
-          </a:prstGeom>
-          <a:noFill/>
-        </p:spPr>
-        <p:txBody>
-          <a:bodyPr wrap="square" lIns="0" rIns="0" tIns="0" bIns="0" anchor="ctr">
-            <a:spAutoFit/>
-          </a:bodyPr>
-          <a:lstStyle/>
-          <a:p>
-            <a:pPr algn="ctr"/>
-            <a:r>
-              <a:rPr sz="1050" b="0" spc="120">
-                <a:solidFill>
-                  <a:srgbClr val="FFFFFF"/>
-                </a:solidFill>
-                <a:latin typeface="Armin Grotesk SemiBold"/>
-              </a:rPr>
-              <a:t>SOPORTE DE MARKETING</a:t>
-            </a:r>
-          </a:p>
-        </p:txBody>
-      </p:sp>
-      <p:sp>
-        <p:nvSpPr>
-          <p:cNvPr id="10" name="TextBox 9"/>
-          <p:cNvSpPr txBox="1"/>
-          <p:nvPr/>
-        </p:nvSpPr>
-        <p:spPr>
-          <a:xfrm>
-            <a:off x="640080" y="2377440"/>
-            <a:ext cx="3200400" cy="548640"/>
-          </a:xfrm>
-          <a:prstGeom prst="rect">
-            <a:avLst/>
-          </a:prstGeom>
-          <a:noFill/>
-        </p:spPr>
-        <p:txBody>
-          <a:bodyPr wrap="square" lIns="0" rIns="0" tIns="0" bIns="0" anchor="t">
-            <a:spAutoFit/>
-          </a:bodyPr>
-          <a:lstStyle/>
-          <a:p>
-            <a:pPr algn="l"/>
-            <a:r>
-              <a:rPr sz="4000" b="0">
-                <a:solidFill>
-                  <a:srgbClr val="1A56DB"/>
-                </a:solidFill>
-                <a:latin typeface="Armin Grotesk Black"/>
-              </a:rPr>
-              <a:t>2.9M</a:t>
-            </a:r>
-          </a:p>
-        </p:txBody>
-      </p:sp>
-      <p:sp>
-        <p:nvSpPr>
-          <p:cNvPr id="11" name="TextBox 10"/>
-          <p:cNvSpPr txBox="1"/>
-          <p:nvPr/>
-        </p:nvSpPr>
-        <p:spPr>
-          <a:xfrm>
-            <a:off x="640080" y="3008060"/>
-            <a:ext cx="3200400" cy="320040"/>
-          </a:xfrm>
-          <a:prstGeom prst="rect">
-            <a:avLst/>
-          </a:prstGeom>
-          <a:noFill/>
-        </p:spPr>
-        <p:txBody>
-          <a:bodyPr wrap="square" lIns="0" rIns="0" tIns="0" bIns="0" anchor="t">
-            <a:spAutoFit/>
-          </a:bodyPr>
-          <a:lstStyle/>
-          <a:p>
-            <a:pPr algn="l"/>
-            <a:r>
-              <a:rPr sz="1100" b="0" spc="60">
-                <a:solidFill>
-                  <a:srgbClr val="6B7280"/>
-                </a:solidFill>
-                <a:latin typeface="Armin Grotesk SemiBold"/>
-              </a:rPr>
-              <a:t>IMPRESIONES GESTIONADAS</a:t>
-            </a:r>
-          </a:p>
-        </p:txBody>
-      </p:sp>
-      <p:sp>
-        <p:nvSpPr>
-          <p:cNvPr id="12" name="TextBox 11"/>
-          <p:cNvSpPr txBox="1"/>
-          <p:nvPr/>
-        </p:nvSpPr>
-        <p:spPr>
-          <a:xfrm>
-            <a:off x="640080" y="3566160"/>
-            <a:ext cx="3291840" cy="2286000"/>
-          </a:xfrm>
-          <a:prstGeom prst="rect">
-            <a:avLst/>
-          </a:prstGeom>
-          <a:noFill/>
-        </p:spPr>
-        <p:txBody>
-          <a:bodyPr wrap="square" lIns="0" rIns="0" tIns="0" bIns="0" anchor="t">
-            <a:spAutoFit/>
-          </a:bodyPr>
-          <a:lstStyle/>
-          <a:p>
-            <a:pPr algn="l">
-              <a:lnSpc>
-                <a:spcPct val="135000"/>
-              </a:lnSpc>
-            </a:pPr>
-            <a:r>
-              <a:rPr sz="1250" b="0">
-                <a:solidFill>
-                  <a:srgbClr val="6B7280"/>
-                </a:solidFill>
-                <a:latin typeface="Armin Grotesk"/>
-              </a:rPr>
-              <a:t>Acompanamos a tu equipo de principio a fin: estrategia, ejecucion y medicion en un solo lugar.</a:t>
-            </a:r>
-          </a:p>
-        </p:txBody>
-      </p:sp>
-      <p:sp>
-        <p:nvSpPr>
-          <p:cNvPr id="13" name="Rounded Rectangle 12"/>
+          <p:cNvPr id="18" name="Rounded Rectangle 17"/>
           <p:cNvSpPr/>
           <p:nvPr/>
         </p:nvSpPr>
         <p:spPr>
           <a:xfrm>
-            <a:off x="8595360" y="2103120"/>
-            <a:ext cx="3017520" cy="3291840"/>
+            <a:off x="10194645" y="3354019"/>
+            <a:ext cx="392277" cy="1382572"/>
           </a:xfrm>
           <a:prstGeom prst="roundRect">
             <a:avLst>
-              <a:gd name="adj" fmla="val 6000"/>
+              <a:gd name="adj" fmla="val 20000"/>
             </a:avLst>
           </a:prstGeom>
           <a:solidFill>
-            <a:srgbClr val="FDE9D6"/>
+            <a:srgbClr val="FBB900"/>
           </a:solidFill>
           <a:ln>
             <a:noFill/>
@@ -7581,61 +8085,19 @@
       </p:sp>
       <p:sp>
         <p:nvSpPr>
-          <p:cNvPr id="14" name="Oval 13"/>
+          <p:cNvPr id="19" name="Rounded Rectangle 18"/>
           <p:cNvSpPr/>
           <p:nvPr/>
         </p:nvSpPr>
         <p:spPr>
           <a:xfrm>
-            <a:off x="9742017" y="3386937"/>
-            <a:ext cx="724204" cy="724204"/>
-          </a:xfrm>
-          <a:prstGeom prst="ellipse">
-            <a:avLst/>
-          </a:prstGeom>
-          <a:solidFill>
-            <a:srgbClr val="FFFFFF"/>
-          </a:solidFill>
-          <a:ln>
-            <a:noFill/>
-          </a:ln>
-          <a:effectLst/>
-        </p:spPr>
-        <p:style>
-          <a:lnRef idx="1">
-            <a:schemeClr val="accent1"/>
-          </a:lnRef>
-          <a:fillRef idx="3">
-            <a:schemeClr val="accent1"/>
-          </a:fillRef>
-          <a:effectRef idx="2">
-            <a:schemeClr val="accent1"/>
-          </a:effectRef>
-          <a:fontRef idx="minor">
-            <a:schemeClr val="lt1"/>
-          </a:fontRef>
-        </p:style>
-        <p:txBody>
-          <a:bodyPr rtlCol="0" anchor="ctr"/>
-          <a:lstStyle/>
-          <a:p>
-            <a:pPr algn="ctr"/>
-          </a:p>
-        </p:txBody>
-      </p:sp>
-      <p:sp>
-        <p:nvSpPr>
-          <p:cNvPr id="15" name="Oval 14"/>
-          <p:cNvSpPr/>
-          <p:nvPr/>
-        </p:nvSpPr>
-        <p:spPr>
-          <a:xfrm>
-            <a:off x="9988247" y="3633167"/>
-            <a:ext cx="231745" cy="231745"/>
-          </a:xfrm>
-          <a:prstGeom prst="ellipse">
-            <a:avLst/>
+            <a:off x="10767974" y="2926079"/>
+            <a:ext cx="392277" cy="1810512"/>
+          </a:xfrm>
+          <a:prstGeom prst="roundRect">
+            <a:avLst>
+              <a:gd name="adj" fmla="val 20000"/>
+            </a:avLst>
           </a:prstGeom>
           <a:solidFill>
             <a:srgbClr val="1A56DB"/>
@@ -7667,9 +8129,97 @@
           </a:p>
         </p:txBody>
       </p:sp>
+      <p:sp>
+        <p:nvSpPr>
+          <p:cNvPr id="20" name="Oval 19"/>
+          <p:cNvSpPr/>
+          <p:nvPr/>
+        </p:nvSpPr>
+        <p:spPr>
+          <a:xfrm>
+            <a:off x="9198864" y="2629814"/>
+            <a:ext cx="658368" cy="658368"/>
+          </a:xfrm>
+          <a:prstGeom prst="ellipse">
+            <a:avLst/>
+          </a:prstGeom>
+          <a:solidFill>
+            <a:srgbClr val="1A56DB"/>
+          </a:solidFill>
+          <a:ln>
+            <a:noFill/>
+          </a:ln>
+          <a:effectLst/>
+        </p:spPr>
+        <p:style>
+          <a:lnRef idx="1">
+            <a:schemeClr val="accent1"/>
+          </a:lnRef>
+          <a:fillRef idx="3">
+            <a:schemeClr val="accent1"/>
+          </a:fillRef>
+          <a:effectRef idx="2">
+            <a:schemeClr val="accent1"/>
+          </a:effectRef>
+          <a:fontRef idx="minor">
+            <a:schemeClr val="lt1"/>
+          </a:fontRef>
+        </p:style>
+        <p:txBody>
+          <a:bodyPr rtlCol="0" anchor="ctr"/>
+          <a:lstStyle/>
+          <a:p>
+            <a:pPr algn="ctr"/>
+          </a:p>
+        </p:txBody>
+      </p:sp>
+      <p:sp>
+        <p:nvSpPr>
+          <p:cNvPr id="21" name="Hexagon 20"/>
+          <p:cNvSpPr/>
+          <p:nvPr/>
+        </p:nvSpPr>
+        <p:spPr>
+          <a:xfrm>
+            <a:off x="10586923" y="2563977"/>
+            <a:ext cx="526694" cy="526694"/>
+          </a:xfrm>
+          <a:prstGeom prst="hexagon">
+            <a:avLst/>
+          </a:prstGeom>
+          <a:solidFill>
+            <a:srgbClr val="FBB900"/>
+          </a:solidFill>
+          <a:ln>
+            <a:noFill/>
+          </a:ln>
+          <a:effectLst/>
+        </p:spPr>
+        <p:style>
+          <a:lnRef idx="1">
+            <a:schemeClr val="accent1"/>
+          </a:lnRef>
+          <a:fillRef idx="3">
+            <a:schemeClr val="accent1"/>
+          </a:fillRef>
+          <a:effectRef idx="2">
+            <a:schemeClr val="accent1"/>
+          </a:effectRef>
+          <a:fontRef idx="minor">
+            <a:schemeClr val="lt1"/>
+          </a:fontRef>
+        </p:style>
+        <p:txBody>
+          <a:bodyPr rtlCol="0" anchor="ctr"/>
+          <a:lstStyle/>
+          <a:p>
+            <a:pPr algn="ctr"/>
+          </a:p>
+        </p:txBody>
+      </p:sp>
       <p:pic>
         <p:nvPicPr>
-          <p:cNvPr id="16" name="Picture 15" descr="perpetual-color.png"/>
+          <p:cNvPr id="22" name="Picture 21" descr="perpetual-color.png"/>
           <p:cNvPicPr>
             <a:picLocks noChangeAspect="1"/>
           </p:cNvPicPr>
@@ -7693,7 +8243,7 @@
       </p:pic>
       <p:sp>
         <p:nvSpPr>
-          <p:cNvPr id="17" name="TextBox 16"/>
+          <p:cNvPr id="23" name="TextBox 22"/>
           <p:cNvSpPr txBox="1"/>
           <p:nvPr/>
         </p:nvSpPr>
@@ -7728,7 +8278,7 @@
       </p:sp>
       <p:sp>
         <p:nvSpPr>
-          <p:cNvPr id="18" name="TextBox 17"/>
+          <p:cNvPr id="24" name="TextBox 23"/>
           <p:cNvSpPr txBox="1"/>
           <p:nvPr/>
         </p:nvSpPr>
@@ -9050,10 +9600,142 @@
         </p:nvSpPr>
         <p:spPr>
           <a:xfrm>
-            <a:off x="8240572" y="2205532"/>
-            <a:ext cx="526694" cy="526694"/>
+            <a:off x="7633411" y="2117750"/>
+            <a:ext cx="746150" cy="746150"/>
           </a:xfrm>
           <a:prstGeom prst="ellipse">
+            <a:avLst/>
+          </a:prstGeom>
+          <a:solidFill>
+            <a:srgbClr val="1A56DB"/>
+          </a:solidFill>
+          <a:ln>
+            <a:noFill/>
+          </a:ln>
+          <a:effectLst/>
+        </p:spPr>
+        <p:style>
+          <a:lnRef idx="1">
+            <a:schemeClr val="accent1"/>
+          </a:lnRef>
+          <a:fillRef idx="3">
+            <a:schemeClr val="accent1"/>
+          </a:fillRef>
+          <a:effectRef idx="2">
+            <a:schemeClr val="accent1"/>
+          </a:effectRef>
+          <a:fontRef idx="minor">
+            <a:schemeClr val="lt1"/>
+          </a:fontRef>
+        </p:style>
+        <p:txBody>
+          <a:bodyPr rtlCol="0" anchor="ctr"/>
+          <a:lstStyle/>
+          <a:p>
+            <a:pPr algn="ctr"/>
+          </a:p>
+        </p:txBody>
+      </p:sp>
+      <p:sp>
+        <p:nvSpPr>
+          <p:cNvPr id="7" name="Oval 6"/>
+          <p:cNvSpPr/>
+          <p:nvPr/>
+        </p:nvSpPr>
+        <p:spPr>
+          <a:xfrm>
+            <a:off x="8597188" y="2424988"/>
+            <a:ext cx="482803" cy="482803"/>
+          </a:xfrm>
+          <a:prstGeom prst="ellipse">
+            <a:avLst/>
+          </a:prstGeom>
+          <a:solidFill>
+            <a:srgbClr val="F97316"/>
+          </a:solidFill>
+          <a:ln>
+            <a:noFill/>
+          </a:ln>
+          <a:effectLst/>
+        </p:spPr>
+        <p:style>
+          <a:lnRef idx="1">
+            <a:schemeClr val="accent1"/>
+          </a:lnRef>
+          <a:fillRef idx="3">
+            <a:schemeClr val="accent1"/>
+          </a:fillRef>
+          <a:effectRef idx="2">
+            <a:schemeClr val="accent1"/>
+          </a:effectRef>
+          <a:fontRef idx="minor">
+            <a:schemeClr val="lt1"/>
+          </a:fontRef>
+        </p:style>
+        <p:txBody>
+          <a:bodyPr rtlCol="0" anchor="ctr"/>
+          <a:lstStyle/>
+          <a:p>
+            <a:pPr algn="ctr"/>
+          </a:p>
+        </p:txBody>
+      </p:sp>
+      <p:sp>
+        <p:nvSpPr>
+          <p:cNvPr id="8" name="Oval 7"/>
+          <p:cNvSpPr/>
+          <p:nvPr/>
+        </p:nvSpPr>
+        <p:spPr>
+          <a:xfrm>
+            <a:off x="8441740" y="2820009"/>
+            <a:ext cx="285292" cy="285292"/>
+          </a:xfrm>
+          <a:prstGeom prst="ellipse">
+            <a:avLst/>
+          </a:prstGeom>
+          <a:solidFill>
+            <a:srgbClr val="FBB900"/>
+          </a:solidFill>
+          <a:ln>
+            <a:noFill/>
+          </a:ln>
+          <a:effectLst/>
+        </p:spPr>
+        <p:style>
+          <a:lnRef idx="1">
+            <a:schemeClr val="accent1"/>
+          </a:lnRef>
+          <a:fillRef idx="3">
+            <a:schemeClr val="accent1"/>
+          </a:fillRef>
+          <a:effectRef idx="2">
+            <a:schemeClr val="accent1"/>
+          </a:effectRef>
+          <a:fontRef idx="minor">
+            <a:schemeClr val="lt1"/>
+          </a:fontRef>
+        </p:style>
+        <p:txBody>
+          <a:bodyPr rtlCol="0" anchor="ctr"/>
+          <a:lstStyle/>
+          <a:p>
+            <a:pPr algn="ctr"/>
+          </a:p>
+        </p:txBody>
+      </p:sp>
+      <p:sp>
+        <p:nvSpPr>
+          <p:cNvPr id="9" name="Hexagon 8"/>
+          <p:cNvSpPr/>
+          <p:nvPr/>
+        </p:nvSpPr>
+        <p:spPr>
+          <a:xfrm>
+            <a:off x="8876995" y="1898294"/>
+            <a:ext cx="373075" cy="373075"/>
+          </a:xfrm>
+          <a:prstGeom prst="hexagon">
             <a:avLst/>
           </a:prstGeom>
           <a:solidFill>
@@ -9088,17 +9770,65 @@
       </p:sp>
       <p:sp>
         <p:nvSpPr>
-          <p:cNvPr id="7" name="Oval 6"/>
+          <p:cNvPr id="10" name="Rounded Rectangle 9"/>
           <p:cNvSpPr/>
           <p:nvPr/>
         </p:nvSpPr>
         <p:spPr>
           <a:xfrm>
-            <a:off x="8419648" y="2384608"/>
-            <a:ext cx="168542" cy="168542"/>
-          </a:xfrm>
-          <a:prstGeom prst="ellipse">
-            <a:avLst/>
+            <a:off x="5669280" y="3108960"/>
+            <a:ext cx="3108960" cy="2103120"/>
+          </a:xfrm>
+          <a:prstGeom prst="roundRect">
+            <a:avLst>
+              <a:gd name="adj" fmla="val 6000"/>
+            </a:avLst>
+          </a:prstGeom>
+          <a:solidFill>
+            <a:srgbClr val="FDE9D6"/>
+          </a:solidFill>
+          <a:ln>
+            <a:noFill/>
+          </a:ln>
+          <a:effectLst/>
+        </p:spPr>
+        <p:style>
+          <a:lnRef idx="1">
+            <a:schemeClr val="accent1"/>
+          </a:lnRef>
+          <a:fillRef idx="3">
+            <a:schemeClr val="accent1"/>
+          </a:fillRef>
+          <a:effectRef idx="2">
+            <a:schemeClr val="accent1"/>
+          </a:effectRef>
+          <a:fontRef idx="minor">
+            <a:schemeClr val="lt1"/>
+          </a:fontRef>
+        </p:style>
+        <p:txBody>
+          <a:bodyPr rtlCol="0" anchor="ctr"/>
+          <a:lstStyle/>
+          <a:p>
+            <a:pPr algn="ctr"/>
+          </a:p>
+        </p:txBody>
+      </p:sp>
+      <p:sp>
+        <p:nvSpPr>
+          <p:cNvPr id="11" name="Rounded Rectangle 10"/>
+          <p:cNvSpPr/>
+          <p:nvPr/>
+        </p:nvSpPr>
+        <p:spPr>
+          <a:xfrm>
+            <a:off x="6135624" y="4454956"/>
+            <a:ext cx="404164" cy="336499"/>
+          </a:xfrm>
+          <a:prstGeom prst="roundRect">
+            <a:avLst>
+              <a:gd name="adj" fmla="val 20000"/>
+            </a:avLst>
           </a:prstGeom>
           <a:solidFill>
             <a:srgbClr val="1A56DB"/>
@@ -9132,22 +9862,22 @@
       </p:sp>
       <p:sp>
         <p:nvSpPr>
-          <p:cNvPr id="8" name="Rounded Rectangle 7"/>
+          <p:cNvPr id="12" name="Rounded Rectangle 11"/>
           <p:cNvSpPr/>
           <p:nvPr/>
         </p:nvSpPr>
         <p:spPr>
           <a:xfrm>
-            <a:off x="5669280" y="3108960"/>
-            <a:ext cx="3108960" cy="2103120"/>
+            <a:off x="6726326" y="4181551"/>
+            <a:ext cx="404164" cy="609904"/>
           </a:xfrm>
           <a:prstGeom prst="roundRect">
             <a:avLst>
-              <a:gd name="adj" fmla="val 6000"/>
+              <a:gd name="adj" fmla="val 20000"/>
             </a:avLst>
           </a:prstGeom>
           <a:solidFill>
-            <a:srgbClr val="FDE9D6"/>
+            <a:srgbClr val="F97316"/>
           </a:solidFill>
           <a:ln>
             <a:noFill/>
@@ -9178,20 +9908,22 @@
       </p:sp>
       <p:sp>
         <p:nvSpPr>
-          <p:cNvPr id="9" name="Oval 8"/>
+          <p:cNvPr id="13" name="Rounded Rectangle 12"/>
           <p:cNvSpPr/>
           <p:nvPr/>
         </p:nvSpPr>
         <p:spPr>
           <a:xfrm>
-            <a:off x="6971385" y="3908145"/>
-            <a:ext cx="504748" cy="504748"/>
-          </a:xfrm>
-          <a:prstGeom prst="ellipse">
-            <a:avLst/>
+            <a:off x="7317028" y="3908145"/>
+            <a:ext cx="404164" cy="883310"/>
+          </a:xfrm>
+          <a:prstGeom prst="roundRect">
+            <a:avLst>
+              <a:gd name="adj" fmla="val 20000"/>
+            </a:avLst>
           </a:prstGeom>
           <a:solidFill>
-            <a:srgbClr val="FFFFFF"/>
+            <a:srgbClr val="FBB900"/>
           </a:solidFill>
           <a:ln>
             <a:noFill/>
@@ -9222,17 +9954,19 @@
       </p:sp>
       <p:sp>
         <p:nvSpPr>
-          <p:cNvPr id="10" name="Oval 9"/>
+          <p:cNvPr id="14" name="Rounded Rectangle 13"/>
           <p:cNvSpPr/>
           <p:nvPr/>
         </p:nvSpPr>
         <p:spPr>
           <a:xfrm>
-            <a:off x="7143000" y="4079760"/>
-            <a:ext cx="161519" cy="161519"/>
-          </a:xfrm>
-          <a:prstGeom prst="ellipse">
-            <a:avLst/>
+            <a:off x="7907731" y="3634740"/>
+            <a:ext cx="404164" cy="1156716"/>
+          </a:xfrm>
+          <a:prstGeom prst="roundRect">
+            <a:avLst>
+              <a:gd name="adj" fmla="val 20000"/>
+            </a:avLst>
           </a:prstGeom>
           <a:solidFill>
             <a:srgbClr val="1A56DB"/>
@@ -9266,7 +10000,95 @@
       </p:sp>
       <p:sp>
         <p:nvSpPr>
-          <p:cNvPr id="11" name="Oval 10"/>
+          <p:cNvPr id="15" name="Oval 14"/>
+          <p:cNvSpPr/>
+          <p:nvPr/>
+        </p:nvSpPr>
+        <p:spPr>
+          <a:xfrm>
+            <a:off x="6291072" y="3445459"/>
+            <a:ext cx="420623" cy="420623"/>
+          </a:xfrm>
+          <a:prstGeom prst="ellipse">
+            <a:avLst/>
+          </a:prstGeom>
+          <a:solidFill>
+            <a:srgbClr val="1A56DB"/>
+          </a:solidFill>
+          <a:ln>
+            <a:noFill/>
+          </a:ln>
+          <a:effectLst/>
+        </p:spPr>
+        <p:style>
+          <a:lnRef idx="1">
+            <a:schemeClr val="accent1"/>
+          </a:lnRef>
+          <a:fillRef idx="3">
+            <a:schemeClr val="accent1"/>
+          </a:fillRef>
+          <a:effectRef idx="2">
+            <a:schemeClr val="accent1"/>
+          </a:effectRef>
+          <a:fontRef idx="minor">
+            <a:schemeClr val="lt1"/>
+          </a:fontRef>
+        </p:style>
+        <p:txBody>
+          <a:bodyPr rtlCol="0" anchor="ctr"/>
+          <a:lstStyle/>
+          <a:p>
+            <a:pPr algn="ctr"/>
+          </a:p>
+        </p:txBody>
+      </p:sp>
+      <p:sp>
+        <p:nvSpPr>
+          <p:cNvPr id="16" name="Hexagon 15"/>
+          <p:cNvSpPr/>
+          <p:nvPr/>
+        </p:nvSpPr>
+        <p:spPr>
+          <a:xfrm>
+            <a:off x="7721193" y="3403396"/>
+            <a:ext cx="336499" cy="336499"/>
+          </a:xfrm>
+          <a:prstGeom prst="hexagon">
+            <a:avLst/>
+          </a:prstGeom>
+          <a:solidFill>
+            <a:srgbClr val="FBB900"/>
+          </a:solidFill>
+          <a:ln>
+            <a:noFill/>
+          </a:ln>
+          <a:effectLst/>
+        </p:spPr>
+        <p:style>
+          <a:lnRef idx="1">
+            <a:schemeClr val="accent1"/>
+          </a:lnRef>
+          <a:fillRef idx="3">
+            <a:schemeClr val="accent1"/>
+          </a:fillRef>
+          <a:effectRef idx="2">
+            <a:schemeClr val="accent1"/>
+          </a:effectRef>
+          <a:fontRef idx="minor">
+            <a:schemeClr val="lt1"/>
+          </a:fontRef>
+        </p:style>
+        <p:txBody>
+          <a:bodyPr rtlCol="0" anchor="ctr"/>
+          <a:lstStyle/>
+          <a:p>
+            <a:pPr algn="ctr"/>
+          </a:p>
+        </p:txBody>
+      </p:sp>
+      <p:sp>
+        <p:nvSpPr>
+          <p:cNvPr id="17" name="Oval 16"/>
           <p:cNvSpPr/>
           <p:nvPr/>
         </p:nvSpPr>
@@ -9310,7 +10132,7 @@
       </p:sp>
       <p:sp>
         <p:nvSpPr>
-          <p:cNvPr id="12" name="Rounded Rectangle 11"/>
+          <p:cNvPr id="18" name="Rounded Rectangle 17"/>
           <p:cNvSpPr/>
           <p:nvPr/>
         </p:nvSpPr>
@@ -9362,7 +10184,7 @@
       </p:sp>
       <p:sp>
         <p:nvSpPr>
-          <p:cNvPr id="13" name="TextBox 12"/>
+          <p:cNvPr id="19" name="TextBox 18"/>
           <p:cNvSpPr txBox="1"/>
           <p:nvPr/>
         </p:nvSpPr>
@@ -9397,7 +10219,7 @@
       </p:sp>
       <p:sp>
         <p:nvSpPr>
-          <p:cNvPr id="14" name="TextBox 13"/>
+          <p:cNvPr id="20" name="TextBox 19"/>
           <p:cNvSpPr txBox="1"/>
           <p:nvPr/>
         </p:nvSpPr>
@@ -9436,7 +10258,7 @@
       </p:sp>
       <p:sp>
         <p:nvSpPr>
-          <p:cNvPr id="15" name="TextBox 14"/>
+          <p:cNvPr id="21" name="TextBox 20"/>
           <p:cNvSpPr txBox="1"/>
           <p:nvPr/>
         </p:nvSpPr>
@@ -9471,7 +10293,7 @@
       </p:sp>
       <p:sp>
         <p:nvSpPr>
-          <p:cNvPr id="16" name="TextBox 15"/>
+          <p:cNvPr id="22" name="TextBox 21"/>
           <p:cNvSpPr txBox="1"/>
           <p:nvPr/>
         </p:nvSpPr>
@@ -9506,7 +10328,7 @@
       </p:sp>
       <p:pic>
         <p:nvPicPr>
-          <p:cNvPr id="17" name="Picture 16" descr="perpetual-color.png"/>
+          <p:cNvPr id="23" name="Picture 22" descr="perpetual-color.png"/>
           <p:cNvPicPr>
             <a:picLocks noChangeAspect="1"/>
           </p:cNvPicPr>
@@ -9530,7 +10352,7 @@
       </p:pic>
       <p:sp>
         <p:nvSpPr>
-          <p:cNvPr id="18" name="TextBox 17"/>
+          <p:cNvPr id="24" name="TextBox 23"/>
           <p:cNvSpPr txBox="1"/>
           <p:nvPr/>
         </p:nvSpPr>
@@ -9565,7 +10387,7 @@
       </p:sp>
       <p:sp>
         <p:nvSpPr>
-          <p:cNvPr id="19" name="TextBox 18"/>
+          <p:cNvPr id="25" name="TextBox 24"/>
           <p:cNvSpPr txBox="1"/>
           <p:nvPr/>
         </p:nvSpPr>
@@ -12667,89 +13489,71 @@
       </p:sp>
       <p:sp>
         <p:nvSpPr>
-          <p:cNvPr id="6" name="Oval 5"/>
-          <p:cNvSpPr/>
-          <p:nvPr/>
-        </p:nvSpPr>
-        <p:spPr>
-          <a:xfrm>
-            <a:off x="9912096" y="2139696"/>
-            <a:ext cx="658368" cy="658368"/>
-          </a:xfrm>
-          <a:prstGeom prst="ellipse">
-            <a:avLst/>
-          </a:prstGeom>
-          <a:solidFill>
-            <a:srgbClr val="FFFFFF"/>
-          </a:solidFill>
-          <a:ln>
-            <a:noFill/>
-          </a:ln>
-          <a:effectLst/>
-        </p:spPr>
-        <p:style>
-          <a:lnRef idx="1">
-            <a:schemeClr val="accent1"/>
-          </a:lnRef>
-          <a:fillRef idx="3">
-            <a:schemeClr val="accent1"/>
-          </a:fillRef>
-          <a:effectRef idx="2">
-            <a:schemeClr val="accent1"/>
-          </a:effectRef>
-          <a:fontRef idx="minor">
-            <a:schemeClr val="lt1"/>
-          </a:fontRef>
-        </p:style>
-        <p:txBody>
-          <a:bodyPr rtlCol="0" anchor="ctr"/>
+          <p:cNvPr id="6" name="TextBox 5"/>
+          <p:cNvSpPr txBox="1"/>
+          <p:nvPr/>
+        </p:nvSpPr>
+        <p:spPr>
+          <a:xfrm>
+            <a:off x="8869680" y="976579"/>
+            <a:ext cx="2743200" cy="1554480"/>
+          </a:xfrm>
+          <a:prstGeom prst="rect">
+            <a:avLst/>
+          </a:prstGeom>
+          <a:noFill/>
+        </p:spPr>
+        <p:txBody>
+          <a:bodyPr wrap="square" lIns="0" rIns="0" tIns="0" bIns="0" anchor="t">
+            <a:spAutoFit/>
+          </a:bodyPr>
           <a:lstStyle/>
           <a:p>
             <a:pPr algn="ctr"/>
-          </a:p>
-        </p:txBody>
-      </p:sp>
-      <p:sp>
-        <p:nvSpPr>
-          <p:cNvPr id="7" name="Oval 6"/>
-          <p:cNvSpPr/>
-          <p:nvPr/>
-        </p:nvSpPr>
-        <p:spPr>
-          <a:xfrm>
-            <a:off x="10135941" y="2363541"/>
-            <a:ext cx="210677" cy="210677"/>
-          </a:xfrm>
-          <a:prstGeom prst="ellipse">
-            <a:avLst/>
-          </a:prstGeom>
-          <a:solidFill>
-            <a:srgbClr val="1A56DB"/>
-          </a:solidFill>
-          <a:ln>
-            <a:noFill/>
-          </a:ln>
-          <a:effectLst/>
-        </p:spPr>
-        <p:style>
-          <a:lnRef idx="1">
-            <a:schemeClr val="accent1"/>
-          </a:lnRef>
-          <a:fillRef idx="3">
-            <a:schemeClr val="accent1"/>
-          </a:fillRef>
-          <a:effectRef idx="2">
-            <a:schemeClr val="accent1"/>
-          </a:effectRef>
-          <a:fontRef idx="minor">
-            <a:schemeClr val="lt1"/>
-          </a:fontRef>
-        </p:style>
-        <p:txBody>
-          <a:bodyPr rtlCol="0" anchor="ctr"/>
+            <a:r>
+              <a:rPr sz="8000" b="0">
+                <a:solidFill>
+                  <a:srgbClr val="1A56DB"/>
+                </a:solidFill>
+                <a:latin typeface="Armin Grotesk Black"/>
+              </a:rPr>
+              <a:t>“</a:t>
+            </a:r>
+          </a:p>
+        </p:txBody>
+      </p:sp>
+      <p:sp>
+        <p:nvSpPr>
+          <p:cNvPr id="7" name="TextBox 6"/>
+          <p:cNvSpPr txBox="1"/>
+          <p:nvPr/>
+        </p:nvSpPr>
+        <p:spPr>
+          <a:xfrm>
+            <a:off x="8869680" y="2841955"/>
+            <a:ext cx="2743200" cy="621792"/>
+          </a:xfrm>
+          <a:prstGeom prst="rect">
+            <a:avLst/>
+          </a:prstGeom>
+          <a:noFill/>
+        </p:spPr>
+        <p:txBody>
+          <a:bodyPr wrap="square" lIns="0" rIns="0" tIns="0" bIns="0" anchor="t">
+            <a:spAutoFit/>
+          </a:bodyPr>
           <a:lstStyle/>
           <a:p>
             <a:pPr algn="ctr"/>
+            <a:r>
+              <a:rPr sz="1600" b="0">
+                <a:solidFill>
+                  <a:srgbClr val="FBB900"/>
+                </a:solidFill>
+                <a:latin typeface="Armin Grotesk"/>
+              </a:rPr>
+              <a:t>★ ★ ★ ★ ★</a:t>
+            </a:r>
           </a:p>
         </p:txBody>
       </p:sp>

</xml_diff>

<commit_message>
Portada sin grafica de barras: composicion de marca (circulos + hexagono)
Tambien bienvenida/trabajo pasan a composicion abstracta (sin barras decorativas).
Las barras reales quedan solo en 'Tendencias de mercado'. .pptx y .html.

Co-Authored-By: Claude Opus 4.8 (1M context) <noreply@anthropic.com>
</commit_message>
<xml_diff>
--- a/dist/perpetual-marketing-template.pptx
+++ b/dist/perpetual-marketing-template.pptx
@@ -3424,8 +3424,8 @@
         </p:nvSpPr>
         <p:spPr>
           <a:xfrm>
-            <a:off x="6766560" y="1463040"/>
-            <a:ext cx="2743200" cy="2743200"/>
+            <a:off x="7315200" y="1371600"/>
+            <a:ext cx="3017520" cy="3017520"/>
           </a:xfrm>
           <a:prstGeom prst="ellipse">
             <a:avLst/>
@@ -3462,18 +3462,367 @@
       </p:sp>
       <p:sp>
         <p:nvSpPr>
-          <p:cNvPr id="6" name="Rounded Rectangle 5"/>
+          <p:cNvPr id="6" name="Hexagon 5"/>
           <p:cNvSpPr/>
           <p:nvPr/>
         </p:nvSpPr>
         <p:spPr>
           <a:xfrm>
-            <a:off x="7772400" y="1234440"/>
-            <a:ext cx="3611880" cy="4160520"/>
+            <a:off x="7818120" y="2148840"/>
+            <a:ext cx="1920240" cy="1920240"/>
+          </a:xfrm>
+          <a:prstGeom prst="hexagon">
+            <a:avLst/>
+          </a:prstGeom>
+          <a:solidFill>
+            <a:srgbClr val="FFFFFF"/>
+          </a:solidFill>
+          <a:ln>
+            <a:noFill/>
+          </a:ln>
+          <a:effectLst/>
+        </p:spPr>
+        <p:style>
+          <a:lnRef idx="1">
+            <a:schemeClr val="accent1"/>
+          </a:lnRef>
+          <a:fillRef idx="3">
+            <a:schemeClr val="accent1"/>
+          </a:fillRef>
+          <a:effectRef idx="2">
+            <a:schemeClr val="accent1"/>
+          </a:effectRef>
+          <a:fontRef idx="minor">
+            <a:schemeClr val="lt1"/>
+          </a:fontRef>
+        </p:style>
+        <p:txBody>
+          <a:bodyPr rtlCol="0" anchor="ctr"/>
+          <a:lstStyle/>
+          <a:p>
+            <a:pPr algn="ctr"/>
+          </a:p>
+        </p:txBody>
+      </p:sp>
+      <p:sp>
+        <p:nvSpPr>
+          <p:cNvPr id="7" name="Oval 6"/>
+          <p:cNvSpPr/>
+          <p:nvPr/>
+        </p:nvSpPr>
+        <p:spPr>
+          <a:xfrm>
+            <a:off x="8458200" y="2788920"/>
+            <a:ext cx="640080" cy="640080"/>
+          </a:xfrm>
+          <a:prstGeom prst="ellipse">
+            <a:avLst/>
+          </a:prstGeom>
+          <a:solidFill>
+            <a:srgbClr val="1A56DB"/>
+          </a:solidFill>
+          <a:ln>
+            <a:noFill/>
+          </a:ln>
+          <a:effectLst/>
+        </p:spPr>
+        <p:style>
+          <a:lnRef idx="1">
+            <a:schemeClr val="accent1"/>
+          </a:lnRef>
+          <a:fillRef idx="3">
+            <a:schemeClr val="accent1"/>
+          </a:fillRef>
+          <a:effectRef idx="2">
+            <a:schemeClr val="accent1"/>
+          </a:effectRef>
+          <a:fontRef idx="minor">
+            <a:schemeClr val="lt1"/>
+          </a:fontRef>
+        </p:style>
+        <p:txBody>
+          <a:bodyPr rtlCol="0" anchor="ctr"/>
+          <a:lstStyle/>
+          <a:p>
+            <a:pPr algn="ctr"/>
+          </a:p>
+        </p:txBody>
+      </p:sp>
+      <p:sp>
+        <p:nvSpPr>
+          <p:cNvPr id="8" name="Oval 7"/>
+          <p:cNvSpPr/>
+          <p:nvPr/>
+        </p:nvSpPr>
+        <p:spPr>
+          <a:xfrm>
+            <a:off x="10424160" y="4297680"/>
+            <a:ext cx="731520" cy="731520"/>
+          </a:xfrm>
+          <a:prstGeom prst="ellipse">
+            <a:avLst/>
+          </a:prstGeom>
+          <a:solidFill>
+            <a:srgbClr val="FBB900"/>
+          </a:solidFill>
+          <a:ln>
+            <a:noFill/>
+          </a:ln>
+          <a:effectLst/>
+        </p:spPr>
+        <p:style>
+          <a:lnRef idx="1">
+            <a:schemeClr val="accent1"/>
+          </a:lnRef>
+          <a:fillRef idx="3">
+            <a:schemeClr val="accent1"/>
+          </a:fillRef>
+          <a:effectRef idx="2">
+            <a:schemeClr val="accent1"/>
+          </a:effectRef>
+          <a:fontRef idx="minor">
+            <a:schemeClr val="lt1"/>
+          </a:fontRef>
+        </p:style>
+        <p:txBody>
+          <a:bodyPr rtlCol="0" anchor="ctr"/>
+          <a:lstStyle/>
+          <a:p>
+            <a:pPr algn="ctr"/>
+          </a:p>
+        </p:txBody>
+      </p:sp>
+      <p:sp>
+        <p:nvSpPr>
+          <p:cNvPr id="9" name="TextBox 8"/>
+          <p:cNvSpPr txBox="1"/>
+          <p:nvPr/>
+        </p:nvSpPr>
+        <p:spPr>
+          <a:xfrm>
+            <a:off x="11247120" y="502920"/>
+            <a:ext cx="640080" cy="548640"/>
+          </a:xfrm>
+          <a:prstGeom prst="rect">
+            <a:avLst/>
+          </a:prstGeom>
+          <a:noFill/>
+        </p:spPr>
+        <p:txBody>
+          <a:bodyPr wrap="square" lIns="0" rIns="0" tIns="0" bIns="0" anchor="t">
+            <a:spAutoFit/>
+          </a:bodyPr>
+          <a:lstStyle/>
+          <a:p>
+            <a:pPr algn="l"/>
+            <a:r>
+              <a:rPr sz="3000" b="0">
+                <a:solidFill>
+                  <a:srgbClr val="1A56DB"/>
+                </a:solidFill>
+                <a:latin typeface="Armin Grotesk Black"/>
+              </a:rPr>
+              <a:t>+</a:t>
+            </a:r>
+          </a:p>
+        </p:txBody>
+      </p:sp>
+      <p:sp>
+        <p:nvSpPr>
+          <p:cNvPr id="10" name="TextBox 9"/>
+          <p:cNvSpPr txBox="1"/>
+          <p:nvPr/>
+        </p:nvSpPr>
+        <p:spPr>
+          <a:xfrm>
+            <a:off x="6766560" y="4937760"/>
+            <a:ext cx="548640" cy="457200"/>
+          </a:xfrm>
+          <a:prstGeom prst="rect">
+            <a:avLst/>
+          </a:prstGeom>
+          <a:noFill/>
+        </p:spPr>
+        <p:txBody>
+          <a:bodyPr wrap="square" lIns="0" rIns="0" tIns="0" bIns="0" anchor="t">
+            <a:spAutoFit/>
+          </a:bodyPr>
+          <a:lstStyle/>
+          <a:p>
+            <a:pPr algn="l"/>
+            <a:r>
+              <a:rPr sz="2400" b="0">
+                <a:solidFill>
+                  <a:srgbClr val="F97316"/>
+                </a:solidFill>
+                <a:latin typeface="Armin Grotesk Black"/>
+              </a:rPr>
+              <a:t>+</a:t>
+            </a:r>
+          </a:p>
+        </p:txBody>
+      </p:sp>
+      <p:pic>
+        <p:nvPicPr>
+          <p:cNvPr id="11" name="Picture 10" descr="perpetual-color.png"/>
+          <p:cNvPicPr>
+            <a:picLocks noChangeAspect="1"/>
+          </p:cNvPicPr>
+          <p:nvPr/>
+        </p:nvPicPr>
+        <p:blipFill>
+          <a:blip r:embed="rId2"/>
+          <a:stretch>
+            <a:fillRect/>
+          </a:stretch>
+        </p:blipFill>
+        <p:spPr>
+          <a:xfrm>
+            <a:off x="640080" y="640080"/>
+            <a:ext cx="1371600" cy="164020"/>
+          </a:xfrm>
+          <a:prstGeom prst="rect">
+            <a:avLst/>
+          </a:prstGeom>
+        </p:spPr>
+      </p:pic>
+      <p:sp>
+        <p:nvSpPr>
+          <p:cNvPr id="12" name="TextBox 11"/>
+          <p:cNvSpPr txBox="1"/>
+          <p:nvPr/>
+        </p:nvSpPr>
+        <p:spPr>
+          <a:xfrm>
+            <a:off x="594360" y="1371600"/>
+            <a:ext cx="6400800" cy="1828800"/>
+          </a:xfrm>
+          <a:prstGeom prst="rect">
+            <a:avLst/>
+          </a:prstGeom>
+          <a:noFill/>
+        </p:spPr>
+        <p:txBody>
+          <a:bodyPr wrap="square" lIns="0" rIns="0" tIns="0" bIns="0" anchor="t">
+            <a:spAutoFit/>
+          </a:bodyPr>
+          <a:lstStyle/>
+          <a:p>
+            <a:pPr algn="l">
+              <a:lnSpc>
+                <a:spcPct val="98000"/>
+              </a:lnSpc>
+            </a:pPr>
+            <a:r>
+              <a:rPr sz="4600" b="0">
+                <a:solidFill>
+                  <a:srgbClr val="111827"/>
+                </a:solidFill>
+                <a:latin typeface="Armin Grotesk Black"/>
+              </a:rPr>
+              <a:t>Marketing para
+</a:t>
+            </a:r>
+            <a:r>
+              <a:rPr sz="4600" b="0">
+                <a:solidFill>
+                  <a:srgbClr val="1A56DB"/>
+                </a:solidFill>
+                <a:latin typeface="Armin Grotesk Black"/>
+              </a:rPr>
+              <a:t>tu marca.</a:t>
+            </a:r>
+          </a:p>
+        </p:txBody>
+      </p:sp>
+      <p:sp>
+        <p:nvSpPr>
+          <p:cNvPr id="13" name="TextBox 12"/>
+          <p:cNvSpPr txBox="1"/>
+          <p:nvPr/>
+        </p:nvSpPr>
+        <p:spPr>
+          <a:xfrm>
+            <a:off x="640080" y="3200400"/>
+            <a:ext cx="5669280" cy="274320"/>
+          </a:xfrm>
+          <a:prstGeom prst="rect">
+            <a:avLst/>
+          </a:prstGeom>
+          <a:noFill/>
+        </p:spPr>
+        <p:txBody>
+          <a:bodyPr wrap="square" lIns="0" rIns="0" tIns="0" bIns="0" anchor="t">
+            <a:spAutoFit/>
+          </a:bodyPr>
+          <a:lstStyle/>
+          <a:p>
+            <a:pPr algn="l"/>
+            <a:r>
+              <a:rPr sz="1300" b="0">
+                <a:solidFill>
+                  <a:srgbClr val="111827"/>
+                </a:solidFill>
+                <a:latin typeface="Armin Grotesk SemiBold"/>
+              </a:rPr>
+              <a:t>Estrategia y crecimiento</a:t>
+            </a:r>
+          </a:p>
+        </p:txBody>
+      </p:sp>
+      <p:sp>
+        <p:nvSpPr>
+          <p:cNvPr id="14" name="TextBox 13"/>
+          <p:cNvSpPr txBox="1"/>
+          <p:nvPr/>
+        </p:nvSpPr>
+        <p:spPr>
+          <a:xfrm>
+            <a:off x="640080" y="3520440"/>
+            <a:ext cx="5486400" cy="731520"/>
+          </a:xfrm>
+          <a:prstGeom prst="rect">
+            <a:avLst/>
+          </a:prstGeom>
+          <a:noFill/>
+        </p:spPr>
+        <p:txBody>
+          <a:bodyPr wrap="square" lIns="0" rIns="0" tIns="0" bIns="0" anchor="t">
+            <a:spAutoFit/>
+          </a:bodyPr>
+          <a:lstStyle/>
+          <a:p>
+            <a:pPr algn="l">
+              <a:lnSpc>
+                <a:spcPct val="130000"/>
+              </a:lnSpc>
+            </a:pPr>
+            <a:r>
+              <a:rPr sz="1250" b="0">
+                <a:solidFill>
+                  <a:srgbClr val="6B7280"/>
+                </a:solidFill>
+                <a:latin typeface="Armin Grotesk"/>
+              </a:rPr>
+              <a:t>Convertimos tu marca en resultados medibles con data y creatividad.</a:t>
+            </a:r>
+          </a:p>
+        </p:txBody>
+      </p:sp>
+      <p:sp>
+        <p:nvSpPr>
+          <p:cNvPr id="15" name="Rounded Rectangle 14"/>
+          <p:cNvSpPr/>
+          <p:nvPr/>
+        </p:nvSpPr>
+        <p:spPr>
+          <a:xfrm>
+            <a:off x="640080" y="4983480"/>
+            <a:ext cx="2743200" cy="566928"/>
           </a:xfrm>
           <a:prstGeom prst="roundRect">
             <a:avLst>
-              <a:gd name="adj" fmla="val 6000"/>
+              <a:gd name="adj" fmla="val 50000"/>
             </a:avLst>
           </a:prstGeom>
           <a:solidFill>
@@ -3514,557 +3863,7 @@
       </p:sp>
       <p:sp>
         <p:nvSpPr>
-          <p:cNvPr id="7" name="Rounded Rectangle 6"/>
-          <p:cNvSpPr/>
-          <p:nvPr/>
-        </p:nvSpPr>
-        <p:spPr>
-          <a:xfrm>
-            <a:off x="8314181" y="3897172"/>
-            <a:ext cx="469544" cy="665683"/>
-          </a:xfrm>
-          <a:prstGeom prst="roundRect">
-            <a:avLst>
-              <a:gd name="adj" fmla="val 20000"/>
-            </a:avLst>
-          </a:prstGeom>
-          <a:solidFill>
-            <a:srgbClr val="1A56DB"/>
-          </a:solidFill>
-          <a:ln>
-            <a:noFill/>
-          </a:ln>
-          <a:effectLst/>
-        </p:spPr>
-        <p:style>
-          <a:lnRef idx="1">
-            <a:schemeClr val="accent1"/>
-          </a:lnRef>
-          <a:fillRef idx="3">
-            <a:schemeClr val="accent1"/>
-          </a:fillRef>
-          <a:effectRef idx="2">
-            <a:schemeClr val="accent1"/>
-          </a:effectRef>
-          <a:fontRef idx="minor">
-            <a:schemeClr val="lt1"/>
-          </a:fontRef>
-        </p:style>
-        <p:txBody>
-          <a:bodyPr rtlCol="0" anchor="ctr"/>
-          <a:lstStyle/>
-          <a:p>
-            <a:pPr algn="ctr"/>
-          </a:p>
-        </p:txBody>
-      </p:sp>
-      <p:sp>
-        <p:nvSpPr>
-          <p:cNvPr id="8" name="Rounded Rectangle 7"/>
-          <p:cNvSpPr/>
-          <p:nvPr/>
-        </p:nvSpPr>
-        <p:spPr>
-          <a:xfrm>
-            <a:off x="9000439" y="3356305"/>
-            <a:ext cx="469544" cy="1206550"/>
-          </a:xfrm>
-          <a:prstGeom prst="roundRect">
-            <a:avLst>
-              <a:gd name="adj" fmla="val 20000"/>
-            </a:avLst>
-          </a:prstGeom>
-          <a:solidFill>
-            <a:srgbClr val="F97316"/>
-          </a:solidFill>
-          <a:ln>
-            <a:noFill/>
-          </a:ln>
-          <a:effectLst/>
-        </p:spPr>
-        <p:style>
-          <a:lnRef idx="1">
-            <a:schemeClr val="accent1"/>
-          </a:lnRef>
-          <a:fillRef idx="3">
-            <a:schemeClr val="accent1"/>
-          </a:fillRef>
-          <a:effectRef idx="2">
-            <a:schemeClr val="accent1"/>
-          </a:effectRef>
-          <a:fontRef idx="minor">
-            <a:schemeClr val="lt1"/>
-          </a:fontRef>
-        </p:style>
-        <p:txBody>
-          <a:bodyPr rtlCol="0" anchor="ctr"/>
-          <a:lstStyle/>
-          <a:p>
-            <a:pPr algn="ctr"/>
-          </a:p>
-        </p:txBody>
-      </p:sp>
-      <p:sp>
-        <p:nvSpPr>
-          <p:cNvPr id="9" name="Rounded Rectangle 8"/>
-          <p:cNvSpPr/>
-          <p:nvPr/>
-        </p:nvSpPr>
-        <p:spPr>
-          <a:xfrm>
-            <a:off x="9686696" y="2815437"/>
-            <a:ext cx="469544" cy="1747418"/>
-          </a:xfrm>
-          <a:prstGeom prst="roundRect">
-            <a:avLst>
-              <a:gd name="adj" fmla="val 20000"/>
-            </a:avLst>
-          </a:prstGeom>
-          <a:solidFill>
-            <a:srgbClr val="FBB900"/>
-          </a:solidFill>
-          <a:ln>
-            <a:noFill/>
-          </a:ln>
-          <a:effectLst/>
-        </p:spPr>
-        <p:style>
-          <a:lnRef idx="1">
-            <a:schemeClr val="accent1"/>
-          </a:lnRef>
-          <a:fillRef idx="3">
-            <a:schemeClr val="accent1"/>
-          </a:fillRef>
-          <a:effectRef idx="2">
-            <a:schemeClr val="accent1"/>
-          </a:effectRef>
-          <a:fontRef idx="minor">
-            <a:schemeClr val="lt1"/>
-          </a:fontRef>
-        </p:style>
-        <p:txBody>
-          <a:bodyPr rtlCol="0" anchor="ctr"/>
-          <a:lstStyle/>
-          <a:p>
-            <a:pPr algn="ctr"/>
-          </a:p>
-        </p:txBody>
-      </p:sp>
-      <p:sp>
-        <p:nvSpPr>
-          <p:cNvPr id="10" name="Rounded Rectangle 9"/>
-          <p:cNvSpPr/>
-          <p:nvPr/>
-        </p:nvSpPr>
-        <p:spPr>
-          <a:xfrm>
-            <a:off x="10372953" y="2274570"/>
-            <a:ext cx="469544" cy="2288286"/>
-          </a:xfrm>
-          <a:prstGeom prst="roundRect">
-            <a:avLst>
-              <a:gd name="adj" fmla="val 20000"/>
-            </a:avLst>
-          </a:prstGeom>
-          <a:solidFill>
-            <a:srgbClr val="1A56DB"/>
-          </a:solidFill>
-          <a:ln>
-            <a:noFill/>
-          </a:ln>
-          <a:effectLst/>
-        </p:spPr>
-        <p:style>
-          <a:lnRef idx="1">
-            <a:schemeClr val="accent1"/>
-          </a:lnRef>
-          <a:fillRef idx="3">
-            <a:schemeClr val="accent1"/>
-          </a:fillRef>
-          <a:effectRef idx="2">
-            <a:schemeClr val="accent1"/>
-          </a:effectRef>
-          <a:fontRef idx="minor">
-            <a:schemeClr val="lt1"/>
-          </a:fontRef>
-        </p:style>
-        <p:txBody>
-          <a:bodyPr rtlCol="0" anchor="ctr"/>
-          <a:lstStyle/>
-          <a:p>
-            <a:pPr algn="ctr"/>
-          </a:p>
-        </p:txBody>
-      </p:sp>
-      <p:sp>
-        <p:nvSpPr>
-          <p:cNvPr id="11" name="Oval 10"/>
-          <p:cNvSpPr/>
-          <p:nvPr/>
-        </p:nvSpPr>
-        <p:spPr>
-          <a:xfrm>
-            <a:off x="8494776" y="1900123"/>
-            <a:ext cx="832104" cy="832104"/>
-          </a:xfrm>
-          <a:prstGeom prst="ellipse">
-            <a:avLst/>
-          </a:prstGeom>
-          <a:solidFill>
-            <a:srgbClr val="1A56DB"/>
-          </a:solidFill>
-          <a:ln>
-            <a:noFill/>
-          </a:ln>
-          <a:effectLst/>
-        </p:spPr>
-        <p:style>
-          <a:lnRef idx="1">
-            <a:schemeClr val="accent1"/>
-          </a:lnRef>
-          <a:fillRef idx="3">
-            <a:schemeClr val="accent1"/>
-          </a:fillRef>
-          <a:effectRef idx="2">
-            <a:schemeClr val="accent1"/>
-          </a:effectRef>
-          <a:fontRef idx="minor">
-            <a:schemeClr val="lt1"/>
-          </a:fontRef>
-        </p:style>
-        <p:txBody>
-          <a:bodyPr rtlCol="0" anchor="ctr"/>
-          <a:lstStyle/>
-          <a:p>
-            <a:pPr algn="ctr"/>
-          </a:p>
-        </p:txBody>
-      </p:sp>
-      <p:sp>
-        <p:nvSpPr>
-          <p:cNvPr id="12" name="Hexagon 11"/>
-          <p:cNvSpPr/>
-          <p:nvPr/>
-        </p:nvSpPr>
-        <p:spPr>
-          <a:xfrm>
-            <a:off x="10156240" y="1816912"/>
-            <a:ext cx="665683" cy="665683"/>
-          </a:xfrm>
-          <a:prstGeom prst="hexagon">
-            <a:avLst/>
-          </a:prstGeom>
-          <a:solidFill>
-            <a:srgbClr val="FBB900"/>
-          </a:solidFill>
-          <a:ln>
-            <a:noFill/>
-          </a:ln>
-          <a:effectLst/>
-        </p:spPr>
-        <p:style>
-          <a:lnRef idx="1">
-            <a:schemeClr val="accent1"/>
-          </a:lnRef>
-          <a:fillRef idx="3">
-            <a:schemeClr val="accent1"/>
-          </a:fillRef>
-          <a:effectRef idx="2">
-            <a:schemeClr val="accent1"/>
-          </a:effectRef>
-          <a:fontRef idx="minor">
-            <a:schemeClr val="lt1"/>
-          </a:fontRef>
-        </p:style>
-        <p:txBody>
-          <a:bodyPr rtlCol="0" anchor="ctr"/>
-          <a:lstStyle/>
-          <a:p>
-            <a:pPr algn="ctr"/>
-          </a:p>
-        </p:txBody>
-      </p:sp>
-      <p:sp>
-        <p:nvSpPr>
-          <p:cNvPr id="13" name="Oval 12"/>
-          <p:cNvSpPr/>
-          <p:nvPr/>
-        </p:nvSpPr>
-        <p:spPr>
-          <a:xfrm>
-            <a:off x="7223760" y="2743200"/>
-            <a:ext cx="822960" cy="822960"/>
-          </a:xfrm>
-          <a:prstGeom prst="ellipse">
-            <a:avLst/>
-          </a:prstGeom>
-          <a:solidFill>
-            <a:srgbClr val="FBB900"/>
-          </a:solidFill>
-          <a:ln>
-            <a:noFill/>
-          </a:ln>
-          <a:effectLst/>
-        </p:spPr>
-        <p:style>
-          <a:lnRef idx="1">
-            <a:schemeClr val="accent1"/>
-          </a:lnRef>
-          <a:fillRef idx="3">
-            <a:schemeClr val="accent1"/>
-          </a:fillRef>
-          <a:effectRef idx="2">
-            <a:schemeClr val="accent1"/>
-          </a:effectRef>
-          <a:fontRef idx="minor">
-            <a:schemeClr val="lt1"/>
-          </a:fontRef>
-        </p:style>
-        <p:txBody>
-          <a:bodyPr rtlCol="0" anchor="ctr"/>
-          <a:lstStyle/>
-          <a:p>
-            <a:pPr algn="ctr"/>
-          </a:p>
-        </p:txBody>
-      </p:sp>
-      <p:sp>
-        <p:nvSpPr>
-          <p:cNvPr id="14" name="TextBox 13"/>
-          <p:cNvSpPr txBox="1"/>
-          <p:nvPr/>
-        </p:nvSpPr>
-        <p:spPr>
-          <a:xfrm>
-            <a:off x="11247120" y="502920"/>
-            <a:ext cx="640080" cy="548640"/>
-          </a:xfrm>
-          <a:prstGeom prst="rect">
-            <a:avLst/>
-          </a:prstGeom>
-          <a:noFill/>
-        </p:spPr>
-        <p:txBody>
-          <a:bodyPr wrap="square" lIns="0" rIns="0" tIns="0" bIns="0" anchor="t">
-            <a:spAutoFit/>
-          </a:bodyPr>
-          <a:lstStyle/>
-          <a:p>
-            <a:pPr algn="l"/>
-            <a:r>
-              <a:rPr sz="3000" b="0">
-                <a:solidFill>
-                  <a:srgbClr val="1A56DB"/>
-                </a:solidFill>
-                <a:latin typeface="Armin Grotesk Black"/>
-              </a:rPr>
-              <a:t>+</a:t>
-            </a:r>
-          </a:p>
-        </p:txBody>
-      </p:sp>
-      <p:pic>
-        <p:nvPicPr>
-          <p:cNvPr id="15" name="Picture 14" descr="perpetual-color.png"/>
-          <p:cNvPicPr>
-            <a:picLocks noChangeAspect="1"/>
-          </p:cNvPicPr>
-          <p:nvPr/>
-        </p:nvPicPr>
-        <p:blipFill>
-          <a:blip r:embed="rId2"/>
-          <a:stretch>
-            <a:fillRect/>
-          </a:stretch>
-        </p:blipFill>
-        <p:spPr>
-          <a:xfrm>
-            <a:off x="640080" y="640080"/>
-            <a:ext cx="1371600" cy="164020"/>
-          </a:xfrm>
-          <a:prstGeom prst="rect">
-            <a:avLst/>
-          </a:prstGeom>
-        </p:spPr>
-      </p:pic>
-      <p:sp>
-        <p:nvSpPr>
           <p:cNvPr id="16" name="TextBox 15"/>
-          <p:cNvSpPr txBox="1"/>
-          <p:nvPr/>
-        </p:nvSpPr>
-        <p:spPr>
-          <a:xfrm>
-            <a:off x="594360" y="1371600"/>
-            <a:ext cx="6400800" cy="1828800"/>
-          </a:xfrm>
-          <a:prstGeom prst="rect">
-            <a:avLst/>
-          </a:prstGeom>
-          <a:noFill/>
-        </p:spPr>
-        <p:txBody>
-          <a:bodyPr wrap="square" lIns="0" rIns="0" tIns="0" bIns="0" anchor="t">
-            <a:spAutoFit/>
-          </a:bodyPr>
-          <a:lstStyle/>
-          <a:p>
-            <a:pPr algn="l">
-              <a:lnSpc>
-                <a:spcPct val="98000"/>
-              </a:lnSpc>
-            </a:pPr>
-            <a:r>
-              <a:rPr sz="4600" b="0">
-                <a:solidFill>
-                  <a:srgbClr val="111827"/>
-                </a:solidFill>
-                <a:latin typeface="Armin Grotesk Black"/>
-              </a:rPr>
-              <a:t>Marketing para
-</a:t>
-            </a:r>
-            <a:r>
-              <a:rPr sz="4600" b="0">
-                <a:solidFill>
-                  <a:srgbClr val="1A56DB"/>
-                </a:solidFill>
-                <a:latin typeface="Armin Grotesk Black"/>
-              </a:rPr>
-              <a:t>tu marca.</a:t>
-            </a:r>
-          </a:p>
-        </p:txBody>
-      </p:sp>
-      <p:sp>
-        <p:nvSpPr>
-          <p:cNvPr id="17" name="TextBox 16"/>
-          <p:cNvSpPr txBox="1"/>
-          <p:nvPr/>
-        </p:nvSpPr>
-        <p:spPr>
-          <a:xfrm>
-            <a:off x="640080" y="3200400"/>
-            <a:ext cx="5669280" cy="274320"/>
-          </a:xfrm>
-          <a:prstGeom prst="rect">
-            <a:avLst/>
-          </a:prstGeom>
-          <a:noFill/>
-        </p:spPr>
-        <p:txBody>
-          <a:bodyPr wrap="square" lIns="0" rIns="0" tIns="0" bIns="0" anchor="t">
-            <a:spAutoFit/>
-          </a:bodyPr>
-          <a:lstStyle/>
-          <a:p>
-            <a:pPr algn="l"/>
-            <a:r>
-              <a:rPr sz="1300" b="0">
-                <a:solidFill>
-                  <a:srgbClr val="111827"/>
-                </a:solidFill>
-                <a:latin typeface="Armin Grotesk SemiBold"/>
-              </a:rPr>
-              <a:t>Estrategia y crecimiento</a:t>
-            </a:r>
-          </a:p>
-        </p:txBody>
-      </p:sp>
-      <p:sp>
-        <p:nvSpPr>
-          <p:cNvPr id="18" name="TextBox 17"/>
-          <p:cNvSpPr txBox="1"/>
-          <p:nvPr/>
-        </p:nvSpPr>
-        <p:spPr>
-          <a:xfrm>
-            <a:off x="640080" y="3520440"/>
-            <a:ext cx="5486400" cy="731520"/>
-          </a:xfrm>
-          <a:prstGeom prst="rect">
-            <a:avLst/>
-          </a:prstGeom>
-          <a:noFill/>
-        </p:spPr>
-        <p:txBody>
-          <a:bodyPr wrap="square" lIns="0" rIns="0" tIns="0" bIns="0" anchor="t">
-            <a:spAutoFit/>
-          </a:bodyPr>
-          <a:lstStyle/>
-          <a:p>
-            <a:pPr algn="l">
-              <a:lnSpc>
-                <a:spcPct val="130000"/>
-              </a:lnSpc>
-            </a:pPr>
-            <a:r>
-              <a:rPr sz="1250" b="0">
-                <a:solidFill>
-                  <a:srgbClr val="6B7280"/>
-                </a:solidFill>
-                <a:latin typeface="Armin Grotesk"/>
-              </a:rPr>
-              <a:t>Convertimos tu marca en resultados medibles con data y creatividad.</a:t>
-            </a:r>
-          </a:p>
-        </p:txBody>
-      </p:sp>
-      <p:sp>
-        <p:nvSpPr>
-          <p:cNvPr id="19" name="Rounded Rectangle 18"/>
-          <p:cNvSpPr/>
-          <p:nvPr/>
-        </p:nvSpPr>
-        <p:spPr>
-          <a:xfrm>
-            <a:off x="640080" y="4983480"/>
-            <a:ext cx="2743200" cy="566928"/>
-          </a:xfrm>
-          <a:prstGeom prst="roundRect">
-            <a:avLst>
-              <a:gd name="adj" fmla="val 50000"/>
-            </a:avLst>
-          </a:prstGeom>
-          <a:solidFill>
-            <a:srgbClr val="FFFFFF"/>
-          </a:solidFill>
-          <a:ln>
-            <a:noFill/>
-          </a:ln>
-          <a:effectLst>
-            <a:outerShdw blurRad="152400" dist="38100" dir="5400000" rotWithShape="0">
-              <a:srgbClr val="1A2B5C">
-                <a:alpha val="12000"/>
-              </a:srgbClr>
-            </a:outerShdw>
-          </a:effectLst>
-        </p:spPr>
-        <p:style>
-          <a:lnRef idx="1">
-            <a:schemeClr val="accent1"/>
-          </a:lnRef>
-          <a:fillRef idx="3">
-            <a:schemeClr val="accent1"/>
-          </a:fillRef>
-          <a:effectRef idx="2">
-            <a:schemeClr val="accent1"/>
-          </a:effectRef>
-          <a:fontRef idx="minor">
-            <a:schemeClr val="lt1"/>
-          </a:fontRef>
-        </p:style>
-        <p:txBody>
-          <a:bodyPr rtlCol="0" anchor="ctr"/>
-          <a:lstStyle/>
-          <a:p>
-            <a:pPr algn="ctr"/>
-          </a:p>
-        </p:txBody>
-      </p:sp>
-      <p:sp>
-        <p:nvSpPr>
-          <p:cNvPr id="20" name="TextBox 19"/>
           <p:cNvSpPr txBox="1"/>
           <p:nvPr/>
         </p:nvSpPr>
@@ -4099,7 +3898,7 @@
       </p:sp>
       <p:sp>
         <p:nvSpPr>
-          <p:cNvPr id="21" name="Oval 20"/>
+          <p:cNvPr id="17" name="Oval 16"/>
           <p:cNvSpPr/>
           <p:nvPr/>
         </p:nvSpPr>
@@ -4143,7 +3942,7 @@
       </p:sp>
       <p:sp>
         <p:nvSpPr>
-          <p:cNvPr id="22" name="TextBox 21"/>
+          <p:cNvPr id="18" name="TextBox 17"/>
           <p:cNvSpPr txBox="1"/>
           <p:nvPr/>
         </p:nvSpPr>
@@ -7947,19 +7746,17 @@
       </p:sp>
       <p:sp>
         <p:nvSpPr>
-          <p:cNvPr id="16" name="Rounded Rectangle 15"/>
+          <p:cNvPr id="16" name="Oval 15"/>
           <p:cNvSpPr/>
           <p:nvPr/>
         </p:nvSpPr>
         <p:spPr>
           <a:xfrm>
-            <a:off x="9047988" y="4209897"/>
-            <a:ext cx="392277" cy="526694"/>
-          </a:xfrm>
-          <a:prstGeom prst="roundRect">
-            <a:avLst>
-              <a:gd name="adj" fmla="val 20000"/>
-            </a:avLst>
+            <a:off x="9259214" y="3222345"/>
+            <a:ext cx="1119225" cy="1119225"/>
+          </a:xfrm>
+          <a:prstGeom prst="ellipse">
+            <a:avLst/>
           </a:prstGeom>
           <a:solidFill>
             <a:srgbClr val="1A56DB"/>
@@ -7993,19 +7790,17 @@
       </p:sp>
       <p:sp>
         <p:nvSpPr>
-          <p:cNvPr id="17" name="Rounded Rectangle 16"/>
+          <p:cNvPr id="17" name="Oval 16"/>
           <p:cNvSpPr/>
           <p:nvPr/>
         </p:nvSpPr>
         <p:spPr>
           <a:xfrm>
-            <a:off x="9621316" y="3781958"/>
-            <a:ext cx="392277" cy="954633"/>
-          </a:xfrm>
-          <a:prstGeom prst="roundRect">
-            <a:avLst>
-              <a:gd name="adj" fmla="val 20000"/>
-            </a:avLst>
+            <a:off x="10194645" y="3683203"/>
+            <a:ext cx="724204" cy="724204"/>
+          </a:xfrm>
+          <a:prstGeom prst="ellipse">
+            <a:avLst/>
           </a:prstGeom>
           <a:solidFill>
             <a:srgbClr val="F97316"/>
@@ -8039,19 +7834,17 @@
       </p:sp>
       <p:sp>
         <p:nvSpPr>
-          <p:cNvPr id="18" name="Rounded Rectangle 17"/>
+          <p:cNvPr id="18" name="Oval 17"/>
           <p:cNvSpPr/>
           <p:nvPr/>
         </p:nvSpPr>
         <p:spPr>
           <a:xfrm>
-            <a:off x="10194645" y="3354019"/>
-            <a:ext cx="392277" cy="1382572"/>
-          </a:xfrm>
-          <a:prstGeom prst="roundRect">
-            <a:avLst>
-              <a:gd name="adj" fmla="val 20000"/>
-            </a:avLst>
+            <a:off x="10043769" y="4275734"/>
+            <a:ext cx="427939" cy="427939"/>
+          </a:xfrm>
+          <a:prstGeom prst="ellipse">
+            <a:avLst/>
           </a:prstGeom>
           <a:solidFill>
             <a:srgbClr val="FBB900"/>
@@ -8085,22 +7878,20 @@
       </p:sp>
       <p:sp>
         <p:nvSpPr>
-          <p:cNvPr id="19" name="Rounded Rectangle 18"/>
+          <p:cNvPr id="19" name="Hexagon 18"/>
           <p:cNvSpPr/>
           <p:nvPr/>
         </p:nvSpPr>
         <p:spPr>
           <a:xfrm>
-            <a:off x="10767974" y="2926079"/>
-            <a:ext cx="392277" cy="1810512"/>
-          </a:xfrm>
-          <a:prstGeom prst="roundRect">
-            <a:avLst>
-              <a:gd name="adj" fmla="val 20000"/>
-            </a:avLst>
+            <a:off x="10466222" y="2893161"/>
+            <a:ext cx="559612" cy="559612"/>
+          </a:xfrm>
+          <a:prstGeom prst="hexagon">
+            <a:avLst/>
           </a:prstGeom>
           <a:solidFill>
-            <a:srgbClr val="1A56DB"/>
+            <a:srgbClr val="FFFFFF"/>
           </a:solidFill>
           <a:ln>
             <a:noFill/>
@@ -8129,97 +7920,9 @@
           </a:p>
         </p:txBody>
       </p:sp>
-      <p:sp>
-        <p:nvSpPr>
-          <p:cNvPr id="20" name="Oval 19"/>
-          <p:cNvSpPr/>
-          <p:nvPr/>
-        </p:nvSpPr>
-        <p:spPr>
-          <a:xfrm>
-            <a:off x="9198864" y="2629814"/>
-            <a:ext cx="658368" cy="658368"/>
-          </a:xfrm>
-          <a:prstGeom prst="ellipse">
-            <a:avLst/>
-          </a:prstGeom>
-          <a:solidFill>
-            <a:srgbClr val="1A56DB"/>
-          </a:solidFill>
-          <a:ln>
-            <a:noFill/>
-          </a:ln>
-          <a:effectLst/>
-        </p:spPr>
-        <p:style>
-          <a:lnRef idx="1">
-            <a:schemeClr val="accent1"/>
-          </a:lnRef>
-          <a:fillRef idx="3">
-            <a:schemeClr val="accent1"/>
-          </a:fillRef>
-          <a:effectRef idx="2">
-            <a:schemeClr val="accent1"/>
-          </a:effectRef>
-          <a:fontRef idx="minor">
-            <a:schemeClr val="lt1"/>
-          </a:fontRef>
-        </p:style>
-        <p:txBody>
-          <a:bodyPr rtlCol="0" anchor="ctr"/>
-          <a:lstStyle/>
-          <a:p>
-            <a:pPr algn="ctr"/>
-          </a:p>
-        </p:txBody>
-      </p:sp>
-      <p:sp>
-        <p:nvSpPr>
-          <p:cNvPr id="21" name="Hexagon 20"/>
-          <p:cNvSpPr/>
-          <p:nvPr/>
-        </p:nvSpPr>
-        <p:spPr>
-          <a:xfrm>
-            <a:off x="10586923" y="2563977"/>
-            <a:ext cx="526694" cy="526694"/>
-          </a:xfrm>
-          <a:prstGeom prst="hexagon">
-            <a:avLst/>
-          </a:prstGeom>
-          <a:solidFill>
-            <a:srgbClr val="FBB900"/>
-          </a:solidFill>
-          <a:ln>
-            <a:noFill/>
-          </a:ln>
-          <a:effectLst/>
-        </p:spPr>
-        <p:style>
-          <a:lnRef idx="1">
-            <a:schemeClr val="accent1"/>
-          </a:lnRef>
-          <a:fillRef idx="3">
-            <a:schemeClr val="accent1"/>
-          </a:fillRef>
-          <a:effectRef idx="2">
-            <a:schemeClr val="accent1"/>
-          </a:effectRef>
-          <a:fontRef idx="minor">
-            <a:schemeClr val="lt1"/>
-          </a:fontRef>
-        </p:style>
-        <p:txBody>
-          <a:bodyPr rtlCol="0" anchor="ctr"/>
-          <a:lstStyle/>
-          <a:p>
-            <a:pPr algn="ctr"/>
-          </a:p>
-        </p:txBody>
-      </p:sp>
       <p:pic>
         <p:nvPicPr>
-          <p:cNvPr id="22" name="Picture 21" descr="perpetual-color.png"/>
+          <p:cNvPr id="20" name="Picture 19" descr="perpetual-color.png"/>
           <p:cNvPicPr>
             <a:picLocks noChangeAspect="1"/>
           </p:cNvPicPr>
@@ -8243,7 +7946,7 @@
       </p:pic>
       <p:sp>
         <p:nvSpPr>
-          <p:cNvPr id="23" name="TextBox 22"/>
+          <p:cNvPr id="21" name="TextBox 20"/>
           <p:cNvSpPr txBox="1"/>
           <p:nvPr/>
         </p:nvSpPr>
@@ -8278,7 +7981,7 @@
       </p:sp>
       <p:sp>
         <p:nvSpPr>
-          <p:cNvPr id="24" name="TextBox 23"/>
+          <p:cNvPr id="22" name="TextBox 21"/>
           <p:cNvSpPr txBox="1"/>
           <p:nvPr/>
         </p:nvSpPr>
@@ -9816,19 +9519,17 @@
       </p:sp>
       <p:sp>
         <p:nvSpPr>
-          <p:cNvPr id="11" name="Rounded Rectangle 10"/>
+          <p:cNvPr id="11" name="Oval 10"/>
           <p:cNvSpPr/>
           <p:nvPr/>
         </p:nvSpPr>
         <p:spPr>
           <a:xfrm>
-            <a:off x="6135624" y="4454956"/>
-            <a:ext cx="404164" cy="336499"/>
-          </a:xfrm>
-          <a:prstGeom prst="roundRect">
-            <a:avLst>
-              <a:gd name="adj" fmla="val 20000"/>
-            </a:avLst>
+            <a:off x="6353251" y="3824020"/>
+            <a:ext cx="715060" cy="715060"/>
+          </a:xfrm>
+          <a:prstGeom prst="ellipse">
+            <a:avLst/>
           </a:prstGeom>
           <a:solidFill>
             <a:srgbClr val="1A56DB"/>
@@ -9862,19 +9563,17 @@
       </p:sp>
       <p:sp>
         <p:nvSpPr>
-          <p:cNvPr id="12" name="Rounded Rectangle 11"/>
+          <p:cNvPr id="12" name="Oval 11"/>
           <p:cNvSpPr/>
           <p:nvPr/>
         </p:nvSpPr>
         <p:spPr>
           <a:xfrm>
-            <a:off x="6726326" y="4181551"/>
-            <a:ext cx="404164" cy="609904"/>
-          </a:xfrm>
-          <a:prstGeom prst="roundRect">
-            <a:avLst>
-              <a:gd name="adj" fmla="val 20000"/>
-            </a:avLst>
+            <a:off x="7317028" y="4118457"/>
+            <a:ext cx="462686" cy="462686"/>
+          </a:xfrm>
+          <a:prstGeom prst="ellipse">
+            <a:avLst/>
           </a:prstGeom>
           <a:solidFill>
             <a:srgbClr val="F97316"/>
@@ -9908,19 +9607,17 @@
       </p:sp>
       <p:sp>
         <p:nvSpPr>
-          <p:cNvPr id="13" name="Rounded Rectangle 12"/>
+          <p:cNvPr id="13" name="Oval 12"/>
           <p:cNvSpPr/>
           <p:nvPr/>
         </p:nvSpPr>
         <p:spPr>
           <a:xfrm>
-            <a:off x="7317028" y="3908145"/>
-            <a:ext cx="404164" cy="883310"/>
-          </a:xfrm>
-          <a:prstGeom prst="roundRect">
-            <a:avLst>
-              <a:gd name="adj" fmla="val 20000"/>
-            </a:avLst>
+            <a:off x="7161580" y="4497019"/>
+            <a:ext cx="273405" cy="273405"/>
+          </a:xfrm>
+          <a:prstGeom prst="ellipse">
+            <a:avLst/>
           </a:prstGeom>
           <a:solidFill>
             <a:srgbClr val="FBB900"/>
@@ -9954,22 +9651,20 @@
       </p:sp>
       <p:sp>
         <p:nvSpPr>
-          <p:cNvPr id="14" name="Rounded Rectangle 13"/>
+          <p:cNvPr id="14" name="Hexagon 13"/>
           <p:cNvSpPr/>
           <p:nvPr/>
         </p:nvSpPr>
         <p:spPr>
           <a:xfrm>
-            <a:off x="7907731" y="3634740"/>
-            <a:ext cx="404164" cy="1156716"/>
-          </a:xfrm>
-          <a:prstGeom prst="roundRect">
-            <a:avLst>
-              <a:gd name="adj" fmla="val 20000"/>
-            </a:avLst>
+            <a:off x="7596835" y="3613708"/>
+            <a:ext cx="357530" cy="357530"/>
+          </a:xfrm>
+          <a:prstGeom prst="hexagon">
+            <a:avLst/>
           </a:prstGeom>
           <a:solidFill>
-            <a:srgbClr val="1A56DB"/>
+            <a:srgbClr val="FFFFFF"/>
           </a:solidFill>
           <a:ln>
             <a:noFill/>
@@ -10001,94 +9696,6 @@
       <p:sp>
         <p:nvSpPr>
           <p:cNvPr id="15" name="Oval 14"/>
-          <p:cNvSpPr/>
-          <p:nvPr/>
-        </p:nvSpPr>
-        <p:spPr>
-          <a:xfrm>
-            <a:off x="6291072" y="3445459"/>
-            <a:ext cx="420623" cy="420623"/>
-          </a:xfrm>
-          <a:prstGeom prst="ellipse">
-            <a:avLst/>
-          </a:prstGeom>
-          <a:solidFill>
-            <a:srgbClr val="1A56DB"/>
-          </a:solidFill>
-          <a:ln>
-            <a:noFill/>
-          </a:ln>
-          <a:effectLst/>
-        </p:spPr>
-        <p:style>
-          <a:lnRef idx="1">
-            <a:schemeClr val="accent1"/>
-          </a:lnRef>
-          <a:fillRef idx="3">
-            <a:schemeClr val="accent1"/>
-          </a:fillRef>
-          <a:effectRef idx="2">
-            <a:schemeClr val="accent1"/>
-          </a:effectRef>
-          <a:fontRef idx="minor">
-            <a:schemeClr val="lt1"/>
-          </a:fontRef>
-        </p:style>
-        <p:txBody>
-          <a:bodyPr rtlCol="0" anchor="ctr"/>
-          <a:lstStyle/>
-          <a:p>
-            <a:pPr algn="ctr"/>
-          </a:p>
-        </p:txBody>
-      </p:sp>
-      <p:sp>
-        <p:nvSpPr>
-          <p:cNvPr id="16" name="Hexagon 15"/>
-          <p:cNvSpPr/>
-          <p:nvPr/>
-        </p:nvSpPr>
-        <p:spPr>
-          <a:xfrm>
-            <a:off x="7721193" y="3403396"/>
-            <a:ext cx="336499" cy="336499"/>
-          </a:xfrm>
-          <a:prstGeom prst="hexagon">
-            <a:avLst/>
-          </a:prstGeom>
-          <a:solidFill>
-            <a:srgbClr val="FBB900"/>
-          </a:solidFill>
-          <a:ln>
-            <a:noFill/>
-          </a:ln>
-          <a:effectLst/>
-        </p:spPr>
-        <p:style>
-          <a:lnRef idx="1">
-            <a:schemeClr val="accent1"/>
-          </a:lnRef>
-          <a:fillRef idx="3">
-            <a:schemeClr val="accent1"/>
-          </a:fillRef>
-          <a:effectRef idx="2">
-            <a:schemeClr val="accent1"/>
-          </a:effectRef>
-          <a:fontRef idx="minor">
-            <a:schemeClr val="lt1"/>
-          </a:fontRef>
-        </p:style>
-        <p:txBody>
-          <a:bodyPr rtlCol="0" anchor="ctr"/>
-          <a:lstStyle/>
-          <a:p>
-            <a:pPr algn="ctr"/>
-          </a:p>
-        </p:txBody>
-      </p:sp>
-      <p:sp>
-        <p:nvSpPr>
-          <p:cNvPr id="17" name="Oval 16"/>
           <p:cNvSpPr/>
           <p:nvPr/>
         </p:nvSpPr>
@@ -10132,7 +9739,7 @@
       </p:sp>
       <p:sp>
         <p:nvSpPr>
-          <p:cNvPr id="18" name="Rounded Rectangle 17"/>
+          <p:cNvPr id="16" name="Rounded Rectangle 15"/>
           <p:cNvSpPr/>
           <p:nvPr/>
         </p:nvSpPr>
@@ -10184,7 +9791,7 @@
       </p:sp>
       <p:sp>
         <p:nvSpPr>
-          <p:cNvPr id="19" name="TextBox 18"/>
+          <p:cNvPr id="17" name="TextBox 16"/>
           <p:cNvSpPr txBox="1"/>
           <p:nvPr/>
         </p:nvSpPr>
@@ -10219,7 +9826,7 @@
       </p:sp>
       <p:sp>
         <p:nvSpPr>
-          <p:cNvPr id="20" name="TextBox 19"/>
+          <p:cNvPr id="18" name="TextBox 17"/>
           <p:cNvSpPr txBox="1"/>
           <p:nvPr/>
         </p:nvSpPr>
@@ -10258,7 +9865,7 @@
       </p:sp>
       <p:sp>
         <p:nvSpPr>
-          <p:cNvPr id="21" name="TextBox 20"/>
+          <p:cNvPr id="19" name="TextBox 18"/>
           <p:cNvSpPr txBox="1"/>
           <p:nvPr/>
         </p:nvSpPr>
@@ -10293,7 +9900,7 @@
       </p:sp>
       <p:sp>
         <p:nvSpPr>
-          <p:cNvPr id="22" name="TextBox 21"/>
+          <p:cNvPr id="20" name="TextBox 19"/>
           <p:cNvSpPr txBox="1"/>
           <p:nvPr/>
         </p:nvSpPr>
@@ -10328,7 +9935,7 @@
       </p:sp>
       <p:pic>
         <p:nvPicPr>
-          <p:cNvPr id="23" name="Picture 22" descr="perpetual-color.png"/>
+          <p:cNvPr id="21" name="Picture 20" descr="perpetual-color.png"/>
           <p:cNvPicPr>
             <a:picLocks noChangeAspect="1"/>
           </p:cNvPicPr>
@@ -10352,7 +9959,7 @@
       </p:pic>
       <p:sp>
         <p:nvSpPr>
-          <p:cNvPr id="24" name="TextBox 23"/>
+          <p:cNvPr id="22" name="TextBox 21"/>
           <p:cNvSpPr txBox="1"/>
           <p:nvPr/>
         </p:nvSpPr>
@@ -10387,7 +9994,7 @@
       </p:sp>
       <p:sp>
         <p:nvSpPr>
-          <p:cNvPr id="25" name="TextBox 24"/>
+          <p:cNvPr id="23" name="TextBox 22"/>
           <p:cNvSpPr txBox="1"/>
           <p:nvPr/>
         </p:nvSpPr>

</xml_diff>

<commit_message>
UX: logo unico arriba en DS-4 (quitar logo del footer, HTML y PPTX)
Co-Authored-By: Claude Opus 4.8 (1M context) <noreply@anthropic.com>
</commit_message>
<xml_diff>
--- a/dist/perpetual-marketing-template.pptx
+++ b/dist/perpetual-marketing-template.pptx
@@ -5067,40 +5067,16 @@
           </a:p>
         </p:txBody>
       </p:sp>
-      <p:pic>
-        <p:nvPicPr>
-          <p:cNvPr id="29" name="Picture 28" descr="perpetual-color.png"/>
-          <p:cNvPicPr>
-            <a:picLocks noChangeAspect="1"/>
-          </p:cNvPicPr>
-          <p:nvPr/>
-        </p:nvPicPr>
-        <p:blipFill>
-          <a:blip r:embed="rId2"/>
-          <a:stretch>
-            <a:fillRect/>
-          </a:stretch>
-        </p:blipFill>
-        <p:spPr>
-          <a:xfrm>
-            <a:off x="502920" y="6437376"/>
-            <a:ext cx="960120" cy="114814"/>
-          </a:xfrm>
-          <a:prstGeom prst="rect">
-            <a:avLst/>
-          </a:prstGeom>
-        </p:spPr>
-      </p:pic>
-      <p:sp>
-        <p:nvSpPr>
-          <p:cNvPr id="30" name="TextBox 29"/>
+      <p:sp>
+        <p:nvSpPr>
+          <p:cNvPr id="29" name="TextBox 28"/>
           <p:cNvSpPr txBox="1"/>
           <p:nvPr/>
         </p:nvSpPr>
         <p:spPr>
           <a:xfrm>
-            <a:off x="1691640" y="6400800"/>
-            <a:ext cx="6400800" cy="274320"/>
+            <a:off x="502920" y="6400800"/>
+            <a:ext cx="7315200" cy="274320"/>
           </a:xfrm>
           <a:prstGeom prst="rect">
             <a:avLst/>
@@ -5128,7 +5104,7 @@
       </p:sp>
       <p:sp>
         <p:nvSpPr>
-          <p:cNvPr id="31" name="TextBox 30"/>
+          <p:cNvPr id="30" name="TextBox 29"/>
           <p:cNvSpPr txBox="1"/>
           <p:nvPr/>
         </p:nvSpPr>
@@ -5649,40 +5625,16 @@
           </a:p>
         </p:txBody>
       </p:sp>
-      <p:pic>
-        <p:nvPicPr>
-          <p:cNvPr id="13" name="Picture 12" descr="perpetual-color.png"/>
-          <p:cNvPicPr>
-            <a:picLocks noChangeAspect="1"/>
-          </p:cNvPicPr>
-          <p:nvPr/>
-        </p:nvPicPr>
-        <p:blipFill>
-          <a:blip r:embed="rId2"/>
-          <a:stretch>
-            <a:fillRect/>
-          </a:stretch>
-        </p:blipFill>
-        <p:spPr>
-          <a:xfrm>
-            <a:off x="502920" y="6437376"/>
-            <a:ext cx="960120" cy="114814"/>
-          </a:xfrm>
-          <a:prstGeom prst="rect">
-            <a:avLst/>
-          </a:prstGeom>
-        </p:spPr>
-      </p:pic>
-      <p:sp>
-        <p:nvSpPr>
-          <p:cNvPr id="14" name="TextBox 13"/>
+      <p:sp>
+        <p:nvSpPr>
+          <p:cNvPr id="13" name="TextBox 12"/>
           <p:cNvSpPr txBox="1"/>
           <p:nvPr/>
         </p:nvSpPr>
         <p:spPr>
           <a:xfrm>
-            <a:off x="1691640" y="6400800"/>
-            <a:ext cx="6400800" cy="274320"/>
+            <a:off x="502920" y="6400800"/>
+            <a:ext cx="7315200" cy="274320"/>
           </a:xfrm>
           <a:prstGeom prst="rect">
             <a:avLst/>
@@ -5710,7 +5662,7 @@
       </p:sp>
       <p:sp>
         <p:nvSpPr>
-          <p:cNvPr id="15" name="TextBox 14"/>
+          <p:cNvPr id="14" name="TextBox 13"/>
           <p:cNvSpPr txBox="1"/>
           <p:nvPr/>
         </p:nvSpPr>
@@ -6367,40 +6319,16 @@
           </a:p>
         </p:txBody>
       </p:sp>
-      <p:pic>
-        <p:nvPicPr>
-          <p:cNvPr id="17" name="Picture 16" descr="perpetual-color.png"/>
-          <p:cNvPicPr>
-            <a:picLocks noChangeAspect="1"/>
-          </p:cNvPicPr>
-          <p:nvPr/>
-        </p:nvPicPr>
-        <p:blipFill>
-          <a:blip r:embed="rId2"/>
-          <a:stretch>
-            <a:fillRect/>
-          </a:stretch>
-        </p:blipFill>
-        <p:spPr>
-          <a:xfrm>
-            <a:off x="502920" y="6437376"/>
-            <a:ext cx="960120" cy="114814"/>
-          </a:xfrm>
-          <a:prstGeom prst="rect">
-            <a:avLst/>
-          </a:prstGeom>
-        </p:spPr>
-      </p:pic>
-      <p:sp>
-        <p:nvSpPr>
-          <p:cNvPr id="18" name="TextBox 17"/>
+      <p:sp>
+        <p:nvSpPr>
+          <p:cNvPr id="17" name="TextBox 16"/>
           <p:cNvSpPr txBox="1"/>
           <p:nvPr/>
         </p:nvSpPr>
         <p:spPr>
           <a:xfrm>
-            <a:off x="1691640" y="6400800"/>
-            <a:ext cx="6400800" cy="274320"/>
+            <a:off x="502920" y="6400800"/>
+            <a:ext cx="7315200" cy="274320"/>
           </a:xfrm>
           <a:prstGeom prst="rect">
             <a:avLst/>
@@ -6428,7 +6356,7 @@
       </p:sp>
       <p:sp>
         <p:nvSpPr>
-          <p:cNvPr id="19" name="TextBox 18"/>
+          <p:cNvPr id="18" name="TextBox 17"/>
           <p:cNvSpPr txBox="1"/>
           <p:nvPr/>
         </p:nvSpPr>
@@ -7920,40 +7848,16 @@
           </a:p>
         </p:txBody>
       </p:sp>
-      <p:pic>
-        <p:nvPicPr>
-          <p:cNvPr id="20" name="Picture 19" descr="perpetual-color.png"/>
-          <p:cNvPicPr>
-            <a:picLocks noChangeAspect="1"/>
-          </p:cNvPicPr>
-          <p:nvPr/>
-        </p:nvPicPr>
-        <p:blipFill>
-          <a:blip r:embed="rId2"/>
-          <a:stretch>
-            <a:fillRect/>
-          </a:stretch>
-        </p:blipFill>
-        <p:spPr>
-          <a:xfrm>
-            <a:off x="502920" y="6437376"/>
-            <a:ext cx="960120" cy="114814"/>
-          </a:xfrm>
-          <a:prstGeom prst="rect">
-            <a:avLst/>
-          </a:prstGeom>
-        </p:spPr>
-      </p:pic>
-      <p:sp>
-        <p:nvSpPr>
-          <p:cNvPr id="21" name="TextBox 20"/>
+      <p:sp>
+        <p:nvSpPr>
+          <p:cNvPr id="20" name="TextBox 19"/>
           <p:cNvSpPr txBox="1"/>
           <p:nvPr/>
         </p:nvSpPr>
         <p:spPr>
           <a:xfrm>
-            <a:off x="1691640" y="6400800"/>
-            <a:ext cx="6400800" cy="274320"/>
+            <a:off x="502920" y="6400800"/>
+            <a:ext cx="7315200" cy="274320"/>
           </a:xfrm>
           <a:prstGeom prst="rect">
             <a:avLst/>
@@ -7981,7 +7885,7 @@
       </p:sp>
       <p:sp>
         <p:nvSpPr>
-          <p:cNvPr id="22" name="TextBox 21"/>
+          <p:cNvPr id="21" name="TextBox 20"/>
           <p:cNvSpPr txBox="1"/>
           <p:nvPr/>
         </p:nvSpPr>
@@ -9012,40 +8916,16 @@
           </a:p>
         </p:txBody>
       </p:sp>
-      <p:pic>
-        <p:nvPicPr>
-          <p:cNvPr id="26" name="Picture 25" descr="perpetual-color.png"/>
-          <p:cNvPicPr>
-            <a:picLocks noChangeAspect="1"/>
-          </p:cNvPicPr>
-          <p:nvPr/>
-        </p:nvPicPr>
-        <p:blipFill>
-          <a:blip r:embed="rId2"/>
-          <a:stretch>
-            <a:fillRect/>
-          </a:stretch>
-        </p:blipFill>
-        <p:spPr>
-          <a:xfrm>
-            <a:off x="502920" y="6437376"/>
-            <a:ext cx="960120" cy="114814"/>
-          </a:xfrm>
-          <a:prstGeom prst="rect">
-            <a:avLst/>
-          </a:prstGeom>
-        </p:spPr>
-      </p:pic>
-      <p:sp>
-        <p:nvSpPr>
-          <p:cNvPr id="27" name="TextBox 26"/>
+      <p:sp>
+        <p:nvSpPr>
+          <p:cNvPr id="26" name="TextBox 25"/>
           <p:cNvSpPr txBox="1"/>
           <p:nvPr/>
         </p:nvSpPr>
         <p:spPr>
           <a:xfrm>
-            <a:off x="1691640" y="6400800"/>
-            <a:ext cx="6400800" cy="274320"/>
+            <a:off x="502920" y="6400800"/>
+            <a:ext cx="7315200" cy="274320"/>
           </a:xfrm>
           <a:prstGeom prst="rect">
             <a:avLst/>
@@ -9073,7 +8953,7 @@
       </p:sp>
       <p:sp>
         <p:nvSpPr>
-          <p:cNvPr id="28" name="TextBox 27"/>
+          <p:cNvPr id="27" name="TextBox 26"/>
           <p:cNvSpPr txBox="1"/>
           <p:nvPr/>
         </p:nvSpPr>
@@ -9933,40 +9813,16 @@
           </a:p>
         </p:txBody>
       </p:sp>
-      <p:pic>
-        <p:nvPicPr>
-          <p:cNvPr id="21" name="Picture 20" descr="perpetual-color.png"/>
-          <p:cNvPicPr>
-            <a:picLocks noChangeAspect="1"/>
-          </p:cNvPicPr>
-          <p:nvPr/>
-        </p:nvPicPr>
-        <p:blipFill>
-          <a:blip r:embed="rId2"/>
-          <a:stretch>
-            <a:fillRect/>
-          </a:stretch>
-        </p:blipFill>
-        <p:spPr>
-          <a:xfrm>
-            <a:off x="502920" y="6437376"/>
-            <a:ext cx="960120" cy="114814"/>
-          </a:xfrm>
-          <a:prstGeom prst="rect">
-            <a:avLst/>
-          </a:prstGeom>
-        </p:spPr>
-      </p:pic>
-      <p:sp>
-        <p:nvSpPr>
-          <p:cNvPr id="22" name="TextBox 21"/>
+      <p:sp>
+        <p:nvSpPr>
+          <p:cNvPr id="21" name="TextBox 20"/>
           <p:cNvSpPr txBox="1"/>
           <p:nvPr/>
         </p:nvSpPr>
         <p:spPr>
           <a:xfrm>
-            <a:off x="1691640" y="6400800"/>
-            <a:ext cx="6400800" cy="274320"/>
+            <a:off x="502920" y="6400800"/>
+            <a:ext cx="7315200" cy="274320"/>
           </a:xfrm>
           <a:prstGeom prst="rect">
             <a:avLst/>
@@ -9994,7 +9850,7 @@
       </p:sp>
       <p:sp>
         <p:nvSpPr>
-          <p:cNvPr id="23" name="TextBox 22"/>
+          <p:cNvPr id="22" name="TextBox 21"/>
           <p:cNvSpPr txBox="1"/>
           <p:nvPr/>
         </p:nvSpPr>
@@ -10818,40 +10674,16 @@
           </a:p>
         </p:txBody>
       </p:sp>
-      <p:pic>
-        <p:nvPicPr>
-          <p:cNvPr id="20" name="Picture 19" descr="perpetual-color.png"/>
-          <p:cNvPicPr>
-            <a:picLocks noChangeAspect="1"/>
-          </p:cNvPicPr>
-          <p:nvPr/>
-        </p:nvPicPr>
-        <p:blipFill>
-          <a:blip r:embed="rId2"/>
-          <a:stretch>
-            <a:fillRect/>
-          </a:stretch>
-        </p:blipFill>
-        <p:spPr>
-          <a:xfrm>
-            <a:off x="502920" y="6437376"/>
-            <a:ext cx="960120" cy="114814"/>
-          </a:xfrm>
-          <a:prstGeom prst="rect">
-            <a:avLst/>
-          </a:prstGeom>
-        </p:spPr>
-      </p:pic>
-      <p:sp>
-        <p:nvSpPr>
-          <p:cNvPr id="21" name="TextBox 20"/>
+      <p:sp>
+        <p:nvSpPr>
+          <p:cNvPr id="20" name="TextBox 19"/>
           <p:cNvSpPr txBox="1"/>
           <p:nvPr/>
         </p:nvSpPr>
         <p:spPr>
           <a:xfrm>
-            <a:off x="1691640" y="6400800"/>
-            <a:ext cx="6400800" cy="274320"/>
+            <a:off x="502920" y="6400800"/>
+            <a:ext cx="7315200" cy="274320"/>
           </a:xfrm>
           <a:prstGeom prst="rect">
             <a:avLst/>
@@ -10879,7 +10711,7 @@
       </p:sp>
       <p:sp>
         <p:nvSpPr>
-          <p:cNvPr id="22" name="TextBox 21"/>
+          <p:cNvPr id="21" name="TextBox 20"/>
           <p:cNvSpPr txBox="1"/>
           <p:nvPr/>
         </p:nvSpPr>
@@ -11266,40 +11098,16 @@
           </a:graphicData>
         </a:graphic>
       </p:graphicFrame>
-      <p:pic>
-        <p:nvPicPr>
-          <p:cNvPr id="11" name="Picture 10" descr="perpetual-color.png"/>
-          <p:cNvPicPr>
-            <a:picLocks noChangeAspect="1"/>
-          </p:cNvPicPr>
-          <p:nvPr/>
-        </p:nvPicPr>
-        <p:blipFill>
-          <a:blip r:embed="rId2"/>
-          <a:stretch>
-            <a:fillRect/>
-          </a:stretch>
-        </p:blipFill>
-        <p:spPr>
-          <a:xfrm>
-            <a:off x="502920" y="6437376"/>
-            <a:ext cx="960120" cy="114814"/>
-          </a:xfrm>
-          <a:prstGeom prst="rect">
-            <a:avLst/>
-          </a:prstGeom>
-        </p:spPr>
-      </p:pic>
-      <p:sp>
-        <p:nvSpPr>
-          <p:cNvPr id="12" name="TextBox 11"/>
+      <p:sp>
+        <p:nvSpPr>
+          <p:cNvPr id="11" name="TextBox 10"/>
           <p:cNvSpPr txBox="1"/>
           <p:nvPr/>
         </p:nvSpPr>
         <p:spPr>
           <a:xfrm>
-            <a:off x="1691640" y="6400800"/>
-            <a:ext cx="6400800" cy="274320"/>
+            <a:off x="502920" y="6400800"/>
+            <a:ext cx="7315200" cy="274320"/>
           </a:xfrm>
           <a:prstGeom prst="rect">
             <a:avLst/>
@@ -11327,7 +11135,7 @@
       </p:sp>
       <p:sp>
         <p:nvSpPr>
-          <p:cNvPr id="13" name="TextBox 12"/>
+          <p:cNvPr id="12" name="TextBox 11"/>
           <p:cNvSpPr txBox="1"/>
           <p:nvPr/>
         </p:nvSpPr>
@@ -11819,40 +11627,16 @@
           </a:p>
         </p:txBody>
       </p:sp>
-      <p:pic>
-        <p:nvPicPr>
-          <p:cNvPr id="13" name="Picture 12" descr="perpetual-color.png"/>
-          <p:cNvPicPr>
-            <a:picLocks noChangeAspect="1"/>
-          </p:cNvPicPr>
-          <p:nvPr/>
-        </p:nvPicPr>
-        <p:blipFill>
-          <a:blip r:embed="rId2"/>
-          <a:stretch>
-            <a:fillRect/>
-          </a:stretch>
-        </p:blipFill>
-        <p:spPr>
-          <a:xfrm>
-            <a:off x="502920" y="6437376"/>
-            <a:ext cx="960120" cy="114814"/>
-          </a:xfrm>
-          <a:prstGeom prst="rect">
-            <a:avLst/>
-          </a:prstGeom>
-        </p:spPr>
-      </p:pic>
-      <p:sp>
-        <p:nvSpPr>
-          <p:cNvPr id="14" name="TextBox 13"/>
+      <p:sp>
+        <p:nvSpPr>
+          <p:cNvPr id="13" name="TextBox 12"/>
           <p:cNvSpPr txBox="1"/>
           <p:nvPr/>
         </p:nvSpPr>
         <p:spPr>
           <a:xfrm>
-            <a:off x="1691640" y="6400800"/>
-            <a:ext cx="6400800" cy="274320"/>
+            <a:off x="502920" y="6400800"/>
+            <a:ext cx="7315200" cy="274320"/>
           </a:xfrm>
           <a:prstGeom prst="rect">
             <a:avLst/>
@@ -11880,7 +11664,7 @@
       </p:sp>
       <p:sp>
         <p:nvSpPr>
-          <p:cNvPr id="15" name="TextBox 14"/>
+          <p:cNvPr id="14" name="TextBox 13"/>
           <p:cNvSpPr txBox="1"/>
           <p:nvPr/>
         </p:nvSpPr>
@@ -12821,40 +12605,16 @@
           </a:p>
         </p:txBody>
       </p:sp>
-      <p:pic>
-        <p:nvPicPr>
-          <p:cNvPr id="24" name="Picture 23" descr="perpetual-color.png"/>
-          <p:cNvPicPr>
-            <a:picLocks noChangeAspect="1"/>
-          </p:cNvPicPr>
-          <p:nvPr/>
-        </p:nvPicPr>
-        <p:blipFill>
-          <a:blip r:embed="rId2"/>
-          <a:stretch>
-            <a:fillRect/>
-          </a:stretch>
-        </p:blipFill>
-        <p:spPr>
-          <a:xfrm>
-            <a:off x="502920" y="6437376"/>
-            <a:ext cx="960120" cy="114814"/>
-          </a:xfrm>
-          <a:prstGeom prst="rect">
-            <a:avLst/>
-          </a:prstGeom>
-        </p:spPr>
-      </p:pic>
-      <p:sp>
-        <p:nvSpPr>
-          <p:cNvPr id="25" name="TextBox 24"/>
+      <p:sp>
+        <p:nvSpPr>
+          <p:cNvPr id="24" name="TextBox 23"/>
           <p:cNvSpPr txBox="1"/>
           <p:nvPr/>
         </p:nvSpPr>
         <p:spPr>
           <a:xfrm>
-            <a:off x="1691640" y="6400800"/>
-            <a:ext cx="6400800" cy="274320"/>
+            <a:off x="502920" y="6400800"/>
+            <a:ext cx="7315200" cy="274320"/>
           </a:xfrm>
           <a:prstGeom prst="rect">
             <a:avLst/>
@@ -12882,7 +12642,7 @@
       </p:sp>
       <p:sp>
         <p:nvSpPr>
-          <p:cNvPr id="26" name="TextBox 25"/>
+          <p:cNvPr id="25" name="TextBox 24"/>
           <p:cNvSpPr txBox="1"/>
           <p:nvPr/>
         </p:nvSpPr>
@@ -13480,40 +13240,16 @@
           </a:p>
         </p:txBody>
       </p:sp>
-      <p:pic>
-        <p:nvPicPr>
-          <p:cNvPr id="15" name="Picture 14" descr="perpetual-color.png"/>
-          <p:cNvPicPr>
-            <a:picLocks noChangeAspect="1"/>
-          </p:cNvPicPr>
-          <p:nvPr/>
-        </p:nvPicPr>
-        <p:blipFill>
-          <a:blip r:embed="rId2"/>
-          <a:stretch>
-            <a:fillRect/>
-          </a:stretch>
-        </p:blipFill>
-        <p:spPr>
-          <a:xfrm>
-            <a:off x="502920" y="6437376"/>
-            <a:ext cx="960120" cy="114814"/>
-          </a:xfrm>
-          <a:prstGeom prst="rect">
-            <a:avLst/>
-          </a:prstGeom>
-        </p:spPr>
-      </p:pic>
-      <p:sp>
-        <p:nvSpPr>
-          <p:cNvPr id="16" name="TextBox 15"/>
+      <p:sp>
+        <p:nvSpPr>
+          <p:cNvPr id="15" name="TextBox 14"/>
           <p:cNvSpPr txBox="1"/>
           <p:nvPr/>
         </p:nvSpPr>
         <p:spPr>
           <a:xfrm>
-            <a:off x="1691640" y="6400800"/>
-            <a:ext cx="6400800" cy="274320"/>
+            <a:off x="502920" y="6400800"/>
+            <a:ext cx="7315200" cy="274320"/>
           </a:xfrm>
           <a:prstGeom prst="rect">
             <a:avLst/>
@@ -13541,7 +13277,7 @@
       </p:sp>
       <p:sp>
         <p:nvSpPr>
-          <p:cNvPr id="17" name="TextBox 16"/>
+          <p:cNvPr id="16" name="TextBox 15"/>
           <p:cNvSpPr txBox="1"/>
           <p:nvPr/>
         </p:nvSpPr>

</xml_diff>